<commit_message>
New home banner, fix audio running times
</commit_message>
<xml_diff>
--- a/downloads/slides/Lesson10_Slides.pptx
+++ b/downloads/slides/Lesson10_Slides.pptx
@@ -963,7 +963,7 @@
           <a:p>
             <a:r>
               <a:rPr lang="en-US" dirty="0"/>
-              <a:t>Step 3 · 6:18–6:30 · Listening + "Say it" (L10_listening.mp3, about 1:30). Audio: L10_listening.mp3 (about 1:30). The audio plays once, play again if needed. Audio coming soon: until it is ready, read the script with a volunteer learner.</a:t>
+              <a:t>Step 3 · 6:18–6:30 · Listening + "Say it" (L10_listening.mp3, about 1:01). Audio: L10_listening.mp3 (about 1:01). The audio plays once, play again if needed. No speaker? Read the script with a volunteer learner.</a:t>
             </a:r>
           </a:p>
           <a:p>
@@ -4684,7 +4684,7 @@
 
 <file path=ppt/slides/slide11.xml><?xml version="1.0" encoding="utf-8"?>
 <p:sld xmlns:a="http://schemas.openxmlformats.org/drawingml/2006/main" xmlns:r="http://schemas.openxmlformats.org/officeDocument/2006/relationships" xmlns:p="http://schemas.openxmlformats.org/presentationml/2006/main">
-  <p:cSld name="Slide 4">
+  <p:cSld name="Slide 9">
     <p:bg>
       <p:bgPr>
         <a:solidFill>
@@ -4714,8 +4714,32 @@
         </p:nvSpPr>
         <p:spPr>
           <a:xfrm>
-            <a:off x="6742786" y="3649370"/>
-            <a:ext cx="4912157" cy="2561234"/>
+            <a:off x="0" y="0"/>
+            <a:ext cx="3063240" cy="6858000"/>
+          </a:xfrm>
+          <a:prstGeom prst="rect">
+            <a:avLst/>
+          </a:prstGeom>
+          <a:solidFill>
+            <a:srgbClr val="B9D2F7"/>
+          </a:solidFill>
+          <a:ln/>
+        </p:spPr>
+        <p:txBody>
+          <a:bodyPr/>
+          <a:p/>
+        </p:txBody>
+      </p:sp>
+      <p:sp>
+        <p:nvSpPr>
+          <p:cNvPr id="4" name="Shape 2"/>
+          <p:cNvSpPr/>
+          <p:nvPr/>
+        </p:nvSpPr>
+        <p:spPr>
+          <a:xfrm>
+            <a:off x="8156448" y="1289304"/>
+            <a:ext cx="3429000" cy="4983480"/>
           </a:xfrm>
           <a:prstGeom prst="round1Rect">
             <a:avLst>
@@ -4723,14 +4747,9 @@
             </a:avLst>
           </a:prstGeom>
           <a:solidFill>
-            <a:srgbClr val="B9D2F7"/>
-          </a:solidFill>
-          <a:ln w="76200">
-            <a:solidFill>
-              <a:srgbClr val="FFFFFF"/>
-            </a:solidFill>
-            <a:prstDash val="solid"/>
-          </a:ln>
+            <a:srgbClr val="8FAFE3"/>
+          </a:solidFill>
+          <a:ln/>
         </p:spPr>
         <p:txBody>
           <a:bodyPr/>
@@ -4745,8 +4764,34 @@
         </p:nvSpPr>
         <p:spPr>
           <a:xfrm>
-            <a:off x="560116" y="1350752"/>
-            <a:ext cx="5663794" cy="1566367"/>
+            <a:off x="8321040" y="1097280"/>
+            <a:ext cx="3429000" cy="4983480"/>
+          </a:xfrm>
+          <a:prstGeom prst="round1Rect">
+            <a:avLst>
+              <a:gd name="adj" fmla="val 23087"/>
+            </a:avLst>
+          </a:prstGeom>
+          <a:solidFill>
+            <a:srgbClr val="B9D2F7"/>
+          </a:solidFill>
+          <a:ln/>
+        </p:spPr>
+        <p:txBody>
+          <a:bodyPr/>
+          <a:p/>
+        </p:txBody>
+      </p:sp>
+      <p:sp>
+        <p:nvSpPr>
+          <p:cNvPr id="6" name="Shape 4"/>
+          <p:cNvSpPr/>
+          <p:nvPr/>
+        </p:nvSpPr>
+        <p:spPr>
+          <a:xfrm>
+            <a:off x="3394847" y="1032586"/>
+            <a:ext cx="4424782" cy="1863547"/>
           </a:xfrm>
           <a:prstGeom prst="roundRect">
             <a:avLst>
@@ -4765,14 +4810,14 @@
       </p:sp>
       <p:sp>
         <p:nvSpPr>
-          <p:cNvPr id="6" name="Shape 4"/>
-          <p:cNvSpPr/>
-          <p:nvPr/>
-        </p:nvSpPr>
-        <p:spPr>
-          <a:xfrm>
-            <a:off x="593446" y="1286561"/>
-            <a:ext cx="5663794" cy="1566367"/>
+          <p:cNvPr id="7" name="Shape 5"/>
+          <p:cNvSpPr/>
+          <p:nvPr/>
+        </p:nvSpPr>
+        <p:spPr>
+          <a:xfrm>
+            <a:off x="3420770" y="956462"/>
+            <a:ext cx="4424782" cy="1863547"/>
           </a:xfrm>
           <a:prstGeom prst="roundRect">
             <a:avLst>
@@ -4791,14 +4836,14 @@
       </p:sp>
       <p:sp>
         <p:nvSpPr>
-          <p:cNvPr id="7" name="Text 5"/>
-          <p:cNvSpPr/>
-          <p:nvPr/>
-        </p:nvSpPr>
-        <p:spPr>
-          <a:xfrm>
-            <a:off x="832104" y="1371600"/>
-            <a:ext cx="5257800" cy="1417320"/>
+          <p:cNvPr id="8" name="Text 6"/>
+          <p:cNvSpPr/>
+          <p:nvPr/>
+        </p:nvSpPr>
+        <p:spPr>
+          <a:xfrm>
+            <a:off x="3566160" y="1078992"/>
+            <a:ext cx="4114800" cy="749808"/>
           </a:xfrm>
           <a:prstGeom prst="rect">
             <a:avLst/>
@@ -4814,6 +4859,95 @@
               <a:buNone/>
             </a:pPr>
             <a:r>
+              <a:rPr lang="en-US" sz="4400" dirty="0" b="1">
+                <a:solidFill>
+                  <a:srgbClr val="1B2236"/>
+                </a:solidFill>
+                <a:latin typeface="Lexend Deca" pitchFamily="34" charset="0"/>
+                <a:ea typeface="Lexend Deca" pitchFamily="34" charset="-122"/>
+                <a:cs typeface="Lexend Deca" pitchFamily="34" charset="-120"/>
+              </a:rPr>
+              <a:t>What should</a:t>
+            </a:r>
+            <a:endParaRPr lang="en-US" sz="4400" dirty="0"/>
+          </a:p>
+        </p:txBody>
+      </p:sp>
+      <p:sp>
+        <p:nvSpPr>
+          <p:cNvPr id="9" name="Text 7"/>
+          <p:cNvSpPr/>
+          <p:nvPr/>
+        </p:nvSpPr>
+        <p:spPr>
+          <a:xfrm>
+            <a:off x="3566160" y="1828800"/>
+            <a:ext cx="4114800" cy="822960"/>
+          </a:xfrm>
+          <a:prstGeom prst="rect">
+            <a:avLst/>
+          </a:prstGeom>
+          <a:noFill/>
+          <a:ln/>
+        </p:spPr>
+        <p:txBody>
+          <a:bodyPr wrap="square" rtlCol="0" anchor="ctr"/>
+          <a:lstStyle/>
+          <a:p>
+            <a:pPr algn="l" indent="0" marL="0">
+              <a:buNone/>
+            </a:pPr>
+            <a:r>
+              <a:rPr lang="en-US" sz="4400" dirty="0" b="1">
+                <a:solidFill>
+                  <a:srgbClr val="1B2236"/>
+                </a:solidFill>
+                <a:latin typeface="Lexend Deca" pitchFamily="34" charset="0"/>
+                <a:ea typeface="Lexend Deca" pitchFamily="34" charset="-122"/>
+                <a:cs typeface="Lexend Deca" pitchFamily="34" charset="-120"/>
+              </a:rPr>
+              <a:t>I do?</a:t>
+            </a:r>
+            <a:endParaRPr lang="en-US" sz="4400" dirty="0"/>
+          </a:p>
+        </p:txBody>
+      </p:sp>
+      <p:sp>
+        <p:nvSpPr>
+          <p:cNvPr id="10" name="Text 8"/>
+          <p:cNvSpPr/>
+          <p:nvPr/>
+        </p:nvSpPr>
+        <p:spPr>
+          <a:xfrm>
+            <a:off x="3487522" y="3108960"/>
+            <a:ext cx="4206240" cy="868680"/>
+          </a:xfrm>
+          <a:prstGeom prst="rect">
+            <a:avLst/>
+          </a:prstGeom>
+          <a:noFill/>
+          <a:ln/>
+        </p:spPr>
+        <p:txBody>
+          <a:bodyPr wrap="square" lIns="0" tIns="0" rIns="0" bIns="0" rtlCol="0" anchor="ctr"/>
+          <a:lstStyle/>
+          <a:p>
+            <a:pPr algn="l" indent="0" marL="0">
+              <a:buNone/>
+            </a:pPr>
+            <a:r>
+              <a:rPr lang="en-US" sz="2000" dirty="0">
+                <a:solidFill>
+                  <a:srgbClr val="1B2236"/>
+                </a:solidFill>
+                <a:latin typeface="Lexend Deca" pitchFamily="34" charset="0"/>
+                <a:ea typeface="Lexend Deca" pitchFamily="34" charset="-122"/>
+                <a:cs typeface="Lexend Deca" pitchFamily="34" charset="-120"/>
+              </a:rPr>
+              <a:t>should + </a:t>
+            </a:r>
+            <a:r>
               <a:rPr lang="en-US" sz="2000" dirty="0" b="1">
                 <a:solidFill>
                   <a:srgbClr val="5B3FC4"/>
@@ -4822,152 +4956,15 @@
                 <a:ea typeface="Lexend Deca" pitchFamily="34" charset="-122"/>
                 <a:cs typeface="Lexend Deca" pitchFamily="34" charset="-120"/>
               </a:rPr>
-              <a:t>Grammar Box 1</a:t>
+              <a:t>base verb</a:t>
             </a:r>
             <a:endParaRPr lang="en-US" sz="2000" dirty="0"/>
           </a:p>
-          <a:p>
-            <a:pPr algn="l" indent="0" marL="0">
-              <a:buNone/>
-            </a:pPr>
-            <a:r>
-              <a:rPr lang="en-US" sz="3200" dirty="0" b="1">
-                <a:solidFill>
-                  <a:srgbClr val="1B2236"/>
-                </a:solidFill>
-                <a:latin typeface="Lexend Deca" pitchFamily="34" charset="0"/>
-                <a:ea typeface="Lexend Deca" pitchFamily="34" charset="-122"/>
-                <a:cs typeface="Lexend Deca" pitchFamily="34" charset="-120"/>
-              </a:rPr>
-              <a:t>What's the</a:t>
-            </a:r>
-            <a:endParaRPr lang="en-US" sz="3200" dirty="0"/>
-          </a:p>
-          <a:p>
-            <a:pPr algn="l" indent="0" marL="0">
-              <a:buNone/>
-            </a:pPr>
-            <a:r>
-              <a:rPr lang="en-US" sz="3200" dirty="0" b="1">
-                <a:solidFill>
-                  <a:srgbClr val="1B2236"/>
-                </a:solidFill>
-                <a:latin typeface="Lexend Deca" pitchFamily="34" charset="0"/>
-                <a:ea typeface="Lexend Deca" pitchFamily="34" charset="-122"/>
-                <a:cs typeface="Lexend Deca" pitchFamily="34" charset="-120"/>
-              </a:rPr>
-              <a:t>Matter?</a:t>
-            </a:r>
-            <a:endParaRPr lang="en-US" sz="3200" dirty="0"/>
-          </a:p>
-        </p:txBody>
-      </p:sp>
-      <p:sp>
-        <p:nvSpPr>
-          <p:cNvPr id="8" name="Shape 6"/>
-          <p:cNvSpPr/>
-          <p:nvPr/>
-        </p:nvSpPr>
-        <p:spPr>
-          <a:xfrm>
-            <a:off x="1305763" y="3649370"/>
-            <a:ext cx="4790542" cy="2599639"/>
-          </a:xfrm>
-          <a:prstGeom prst="round1Rect">
-            <a:avLst>
-              <a:gd name="adj" fmla="val 23087"/>
-            </a:avLst>
-          </a:prstGeom>
-          <a:solidFill>
-            <a:srgbClr val="FFFFFF"/>
-          </a:solidFill>
-          <a:ln w="25400">
-            <a:solidFill>
-              <a:srgbClr val="8FAFE3"/>
-            </a:solidFill>
-            <a:prstDash val="solid"/>
-          </a:ln>
-        </p:spPr>
-        <p:txBody>
-          <a:bodyPr/>
-          <a:p/>
-        </p:txBody>
-      </p:sp>
-      <p:sp>
-        <p:nvSpPr>
-          <p:cNvPr id="15" name="Shape 13"/>
-          <p:cNvSpPr/>
-          <p:nvPr/>
-        </p:nvSpPr>
-        <p:spPr>
-          <a:xfrm>
-            <a:off x="741578" y="3253435"/>
-            <a:ext cx="1024128" cy="967435"/>
-          </a:xfrm>
-          <a:prstGeom prst="star10">
-            <a:avLst/>
-          </a:prstGeom>
-          <a:solidFill>
-            <a:srgbClr val="8FAFE3"/>
-          </a:solidFill>
-          <a:ln/>
-        </p:spPr>
-        <p:txBody>
-          <a:bodyPr/>
-          <a:p/>
-        </p:txBody>
-      </p:sp>
-      <p:sp>
-        <p:nvSpPr>
-          <p:cNvPr id="16" name="Shape 14"/>
-          <p:cNvSpPr/>
-          <p:nvPr/>
-        </p:nvSpPr>
-        <p:spPr>
-          <a:xfrm>
-            <a:off x="823874" y="3240634"/>
-            <a:ext cx="1042416" cy="1042416"/>
-          </a:xfrm>
-          <a:prstGeom prst="star10">
-            <a:avLst/>
-          </a:prstGeom>
-          <a:solidFill>
-            <a:srgbClr val="FFE28C"/>
-          </a:solidFill>
-          <a:ln/>
-        </p:spPr>
-        <p:txBody>
-          <a:bodyPr/>
-          <a:p/>
-        </p:txBody>
-      </p:sp>
-      <p:sp>
-        <p:nvSpPr>
-          <p:cNvPr id="17" name="Shape 15"/>
-          <p:cNvSpPr/>
-          <p:nvPr/>
-        </p:nvSpPr>
-        <p:spPr>
-          <a:xfrm rot="900000">
-            <a:off x="1107338" y="3539642"/>
-            <a:ext cx="445313" cy="445313"/>
-          </a:xfrm>
-          <a:prstGeom prst="mathPlus">
-            <a:avLst/>
-          </a:prstGeom>
-          <a:solidFill>
-            <a:srgbClr val="1B2236"/>
-          </a:solidFill>
-          <a:ln/>
-        </p:spPr>
-        <p:txBody>
-          <a:bodyPr/>
-          <a:p/>
         </p:txBody>
       </p:sp>
       <p:pic>
         <p:nvPicPr>
-          <p:cNvPr id="42" name="Picture 42" descr="L10_headache.png"/>
+          <p:cNvPr id="65" name="Picture 65" descr="L10_rest.png"/>
           <p:cNvPicPr>
             <a:picLocks noChangeAspect="1"/>
           </p:cNvPicPr>
@@ -4981,8 +4978,8 @@
         </p:blipFill>
         <p:spPr>
           <a:xfrm>
-            <a:off x="7598664" y="1216152"/>
-            <a:ext cx="3254350" cy="2278045"/>
+            <a:off x="160020" y="2423160"/>
+            <a:ext cx="2743200" cy="1920240"/>
           </a:xfrm>
           <a:prstGeom prst="rect">
             <a:avLst/>
@@ -4991,14 +4988,14 @@
       </p:pic>
       <p:sp>
         <p:nvSpPr>
-          <p:cNvPr id="43" name="Q head"/>
-          <p:cNvSpPr/>
-          <p:nvPr/>
-        </p:nvSpPr>
-        <p:spPr>
-          <a:xfrm>
-            <a:off x="1920240" y="3794760"/>
-            <a:ext cx="4023360" cy="457200"/>
+          <p:cNvPr id="66" name="Wh"/>
+          <p:cNvSpPr/>
+          <p:nvPr/>
+        </p:nvSpPr>
+        <p:spPr>
+          <a:xfrm>
+            <a:off x="3520440" y="4114800"/>
+            <a:ext cx="907999" cy="530352"/>
           </a:xfrm>
           <a:prstGeom prst="rect">
             <a:avLst/>
@@ -5009,6 +5006,53 @@
           </a:ln>
         </p:spPr>
         <p:txBody>
+          <a:bodyPr wrap="square" lIns="0" tIns="36576" rIns="0" bIns="36576" rtlCol="0" anchor="ctr">
+            <a:noAutofit/>
+          </a:bodyPr>
+          <a:lstStyle/>
+          <a:p>
+            <a:pPr algn="l" indent="0" marL="0">
+              <a:buNone/>
+            </a:pPr>
+            <a:r>
+              <a:rPr lang="en-US" sz="2200" dirty="0">
+                <a:solidFill>
+                  <a:srgbClr val="1B2236"/>
+                </a:solidFill>
+                <a:latin typeface="Lexend Deca" pitchFamily="34" charset="0"/>
+                <a:ea typeface="Lexend Deca" pitchFamily="34" charset="-122"/>
+                <a:cs typeface="Lexend Deca" pitchFamily="34" charset="-120"/>
+              </a:rPr>
+              <a:t>What</a:t>
+            </a:r>
+            <a:endParaRPr lang="en-US" sz="2200" dirty="0"/>
+          </a:p>
+        </p:txBody>
+      </p:sp>
+      <p:sp>
+        <p:nvSpPr>
+          <p:cNvPr id="67" name="Highlight"/>
+          <p:cNvSpPr/>
+          <p:nvPr/>
+        </p:nvSpPr>
+        <p:spPr>
+          <a:xfrm>
+            <a:off x="4428439" y="4114800"/>
+            <a:ext cx="1306495" cy="530352"/>
+          </a:xfrm>
+          <a:prstGeom prst="roundRect">
+            <a:avLst>
+              <a:gd name="adj" fmla="val 22000"/>
+            </a:avLst>
+          </a:prstGeom>
+          <a:solidFill>
+            <a:srgbClr val="FFE28C"/>
+          </a:solidFill>
+          <a:ln w="38100">
+            <a:noFill/>
+          </a:ln>
+        </p:spPr>
+        <p:txBody>
           <a:bodyPr wrap="square" lIns="73152" tIns="36576" rIns="73152" bIns="36576" rtlCol="0" anchor="ctr">
             <a:noAutofit/>
           </a:bodyPr>
@@ -5018,15 +5062,15 @@
               <a:buNone/>
             </a:pPr>
             <a:r>
-              <a:rPr lang="en-US" sz="2000" dirty="0" b="1">
-                <a:solidFill>
-                  <a:srgbClr val="5B3FC4"/>
-                </a:solidFill>
-                <a:latin typeface="Lexend Deca" pitchFamily="34" charset="0"/>
-                <a:ea typeface="Lexend Deca" pitchFamily="34" charset="-122"/>
-                <a:cs typeface="Lexend Deca" pitchFamily="34" charset="-120"/>
-              </a:rPr>
-              <a:t>QUESTION</a:t>
+              <a:rPr lang="en-US" sz="2000" dirty="0">
+                <a:solidFill>
+                  <a:srgbClr val="1B2236"/>
+                </a:solidFill>
+                <a:latin typeface="Lexend Deca" pitchFamily="34" charset="0"/>
+                <a:ea typeface="Lexend Deca" pitchFamily="34" charset="-122"/>
+                <a:cs typeface="Lexend Deca" pitchFamily="34" charset="-120"/>
+              </a:rPr>
+              <a:t/>
             </a:r>
             <a:endParaRPr lang="en-US" sz="2000" dirty="0"/>
           </a:p>
@@ -5034,14 +5078,14 @@
       </p:sp>
       <p:sp>
         <p:nvSpPr>
-          <p:cNvPr id="44" name="A head"/>
-          <p:cNvSpPr/>
-          <p:nvPr/>
-        </p:nvSpPr>
-        <p:spPr>
-          <a:xfrm>
-            <a:off x="7040880" y="3794760"/>
-            <a:ext cx="4480560" cy="457200"/>
+          <p:cNvPr id="68" name="Helper"/>
+          <p:cNvSpPr/>
+          <p:nvPr/>
+        </p:nvSpPr>
+        <p:spPr>
+          <a:xfrm>
+            <a:off x="4428439" y="4114800"/>
+            <a:ext cx="1306495" cy="530352"/>
           </a:xfrm>
           <a:prstGeom prst="rect">
             <a:avLst/>
@@ -5052,39 +5096,125 @@
           </a:ln>
         </p:spPr>
         <p:txBody>
-          <a:bodyPr wrap="square" lIns="73152" tIns="36576" rIns="73152" bIns="36576" rtlCol="0" anchor="ctr">
+          <a:bodyPr wrap="square" lIns="0" tIns="36576" rIns="0" bIns="36576" rtlCol="0" anchor="ctr">
             <a:noAutofit/>
           </a:bodyPr>
           <a:lstStyle/>
           <a:p>
+            <a:pPr algn="ctr" indent="0" marL="0">
+              <a:buNone/>
+            </a:pPr>
+            <a:r>
+              <a:rPr lang="en-US" sz="2200" dirty="0" b="1">
+                <a:solidFill>
+                  <a:srgbClr val="1B2236"/>
+                </a:solidFill>
+                <a:latin typeface="Lexend Deca" pitchFamily="34" charset="0"/>
+                <a:ea typeface="Lexend Deca" pitchFamily="34" charset="-122"/>
+                <a:cs typeface="Lexend Deca" pitchFamily="34" charset="-120"/>
+              </a:rPr>
+              <a:t>should</a:t>
+            </a:r>
+            <a:endParaRPr lang="en-US" sz="2200" dirty="0"/>
+          </a:p>
+        </p:txBody>
+      </p:sp>
+      <p:sp>
+        <p:nvSpPr>
+          <p:cNvPr id="69" name="Rest"/>
+          <p:cNvSpPr/>
+          <p:nvPr/>
+        </p:nvSpPr>
+        <p:spPr>
+          <a:xfrm>
+            <a:off x="5789798" y="4114800"/>
+            <a:ext cx="937260" cy="530352"/>
+          </a:xfrm>
+          <a:prstGeom prst="rect">
+            <a:avLst/>
+          </a:prstGeom>
+          <a:noFill/>
+          <a:ln w="38100">
+            <a:noFill/>
+          </a:ln>
+        </p:spPr>
+        <p:txBody>
+          <a:bodyPr wrap="square" lIns="0" tIns="36576" rIns="0" bIns="36576" rtlCol="0" anchor="ctr">
+            <a:noAutofit/>
+          </a:bodyPr>
+          <a:lstStyle/>
+          <a:p>
             <a:pPr algn="l" indent="0" marL="0">
               <a:buNone/>
             </a:pPr>
             <a:r>
-              <a:rPr lang="en-US" sz="2000" dirty="0" b="1">
-                <a:solidFill>
-                  <a:srgbClr val="5B3FC4"/>
-                </a:solidFill>
-                <a:latin typeface="Lexend Deca" pitchFamily="34" charset="0"/>
-                <a:ea typeface="Lexend Deca" pitchFamily="34" charset="-122"/>
-                <a:cs typeface="Lexend Deca" pitchFamily="34" charset="-120"/>
-              </a:rPr>
-              <a:t>ANSWER</a:t>
-            </a:r>
-            <a:endParaRPr lang="en-US" sz="2000" dirty="0"/>
-          </a:p>
-        </p:txBody>
-      </p:sp>
-      <p:sp>
-        <p:nvSpPr>
-          <p:cNvPr id="45" name="Highlight"/>
-          <p:cNvSpPr/>
-          <p:nvPr/>
-        </p:nvSpPr>
-        <p:spPr>
-          <a:xfrm>
-            <a:off x="1481328" y="4453128"/>
-            <a:ext cx="3035808" cy="548640"/>
+              <a:rPr lang="en-US" sz="2200" dirty="0">
+                <a:solidFill>
+                  <a:srgbClr val="1B2236"/>
+                </a:solidFill>
+                <a:latin typeface="Lexend Deca" pitchFamily="34" charset="0"/>
+                <a:ea typeface="Lexend Deca" pitchFamily="34" charset="-122"/>
+                <a:cs typeface="Lexend Deca" pitchFamily="34" charset="-120"/>
+              </a:rPr>
+              <a:t>I do?</a:t>
+            </a:r>
+            <a:endParaRPr lang="en-US" sz="2200" dirty="0"/>
+          </a:p>
+        </p:txBody>
+      </p:sp>
+      <p:sp>
+        <p:nvSpPr>
+          <p:cNvPr id="70" name="Wh"/>
+          <p:cNvSpPr/>
+          <p:nvPr/>
+        </p:nvSpPr>
+        <p:spPr>
+          <a:xfrm>
+            <a:off x="3520440" y="4846320"/>
+            <a:ext cx="907999" cy="530352"/>
+          </a:xfrm>
+          <a:prstGeom prst="rect">
+            <a:avLst/>
+          </a:prstGeom>
+          <a:noFill/>
+          <a:ln w="38100">
+            <a:noFill/>
+          </a:ln>
+        </p:spPr>
+        <p:txBody>
+          <a:bodyPr wrap="square" lIns="0" tIns="36576" rIns="0" bIns="36576" rtlCol="0" anchor="ctr">
+            <a:noAutofit/>
+          </a:bodyPr>
+          <a:lstStyle/>
+          <a:p>
+            <a:pPr algn="l" indent="0" marL="0">
+              <a:buNone/>
+            </a:pPr>
+            <a:r>
+              <a:rPr lang="en-US" sz="2200" dirty="0">
+                <a:solidFill>
+                  <a:srgbClr val="1B2236"/>
+                </a:solidFill>
+                <a:latin typeface="Lexend Deca" pitchFamily="34" charset="0"/>
+                <a:ea typeface="Lexend Deca" pitchFamily="34" charset="-122"/>
+                <a:cs typeface="Lexend Deca" pitchFamily="34" charset="-120"/>
+              </a:rPr>
+              <a:t>What</a:t>
+            </a:r>
+            <a:endParaRPr lang="en-US" sz="2200" dirty="0"/>
+          </a:p>
+        </p:txBody>
+      </p:sp>
+      <p:sp>
+        <p:nvSpPr>
+          <p:cNvPr id="71" name="Highlight"/>
+          <p:cNvSpPr/>
+          <p:nvPr/>
+        </p:nvSpPr>
+        <p:spPr>
+          <a:xfrm>
+            <a:off x="4428439" y="4846320"/>
+            <a:ext cx="1306495" cy="530352"/>
           </a:xfrm>
           <a:prstGeom prst="roundRect">
             <a:avLst>
@@ -5124,14 +5254,14 @@
       </p:sp>
       <p:sp>
         <p:nvSpPr>
-          <p:cNvPr id="46" name="Question"/>
-          <p:cNvSpPr/>
-          <p:nvPr/>
-        </p:nvSpPr>
-        <p:spPr>
-          <a:xfrm>
-            <a:off x="1481328" y="4315968"/>
-            <a:ext cx="4526280" cy="822960"/>
+          <p:cNvPr id="72" name="Helper"/>
+          <p:cNvSpPr/>
+          <p:nvPr/>
+        </p:nvSpPr>
+        <p:spPr>
+          <a:xfrm>
+            <a:off x="4428439" y="4846320"/>
+            <a:ext cx="1306495" cy="530352"/>
           </a:xfrm>
           <a:prstGeom prst="rect">
             <a:avLst/>
@@ -5142,11 +5272,54 @@
           </a:ln>
         </p:spPr>
         <p:txBody>
-          <a:bodyPr wrap="square" lIns="73152" tIns="36576" rIns="73152" bIns="36576" rtlCol="0" anchor="ctr">
+          <a:bodyPr wrap="square" lIns="0" tIns="36576" rIns="0" bIns="36576" rtlCol="0" anchor="ctr">
             <a:noAutofit/>
           </a:bodyPr>
           <a:lstStyle/>
           <a:p>
+            <a:pPr algn="ctr" indent="0" marL="0">
+              <a:buNone/>
+            </a:pPr>
+            <a:r>
+              <a:rPr lang="en-US" sz="2200" dirty="0" b="1">
+                <a:solidFill>
+                  <a:srgbClr val="1B2236"/>
+                </a:solidFill>
+                <a:latin typeface="Lexend Deca" pitchFamily="34" charset="0"/>
+                <a:ea typeface="Lexend Deca" pitchFamily="34" charset="-122"/>
+                <a:cs typeface="Lexend Deca" pitchFamily="34" charset="-120"/>
+              </a:rPr>
+              <a:t>should</a:t>
+            </a:r>
+            <a:endParaRPr lang="en-US" sz="2200" dirty="0"/>
+          </a:p>
+        </p:txBody>
+      </p:sp>
+      <p:sp>
+        <p:nvSpPr>
+          <p:cNvPr id="73" name="Rest"/>
+          <p:cNvSpPr/>
+          <p:nvPr/>
+        </p:nvSpPr>
+        <p:spPr>
+          <a:xfrm>
+            <a:off x="5789798" y="4846320"/>
+            <a:ext cx="1088136" cy="530352"/>
+          </a:xfrm>
+          <a:prstGeom prst="rect">
+            <a:avLst/>
+          </a:prstGeom>
+          <a:noFill/>
+          <a:ln w="38100">
+            <a:noFill/>
+          </a:ln>
+        </p:spPr>
+        <p:txBody>
+          <a:bodyPr wrap="square" lIns="0" tIns="36576" rIns="0" bIns="36576" rtlCol="0" anchor="ctr">
+            <a:noAutofit/>
+          </a:bodyPr>
+          <a:lstStyle/>
+          <a:p>
             <a:pPr algn="l" indent="0" marL="0">
               <a:buNone/>
             </a:pPr>
@@ -5159,19 +5332,40 @@
                 <a:ea typeface="Lexend Deca" pitchFamily="34" charset="-122"/>
                 <a:cs typeface="Lexend Deca" pitchFamily="34" charset="-120"/>
               </a:rPr>
-              <a:t>What's </a:t>
-            </a:r>
-            <a:r>
-              <a:rPr lang="en-US" sz="2200" dirty="0" b="1">
-                <a:solidFill>
-                  <a:srgbClr val="1B2236"/>
-                </a:solidFill>
-                <a:latin typeface="Lexend Deca" pitchFamily="34" charset="0"/>
-                <a:ea typeface="Lexend Deca" pitchFamily="34" charset="-122"/>
-                <a:cs typeface="Lexend Deca" pitchFamily="34" charset="-120"/>
-              </a:rPr>
-              <a:t>the matter</a:t>
-            </a:r>
+              <a:t>he do?</a:t>
+            </a:r>
+            <a:endParaRPr lang="en-US" sz="2200" dirty="0"/>
+          </a:p>
+        </p:txBody>
+      </p:sp>
+      <p:sp>
+        <p:nvSpPr>
+          <p:cNvPr id="74" name="Wh"/>
+          <p:cNvSpPr/>
+          <p:nvPr/>
+        </p:nvSpPr>
+        <p:spPr>
+          <a:xfrm>
+            <a:off x="3520440" y="5577840"/>
+            <a:ext cx="907999" cy="530352"/>
+          </a:xfrm>
+          <a:prstGeom prst="rect">
+            <a:avLst/>
+          </a:prstGeom>
+          <a:noFill/>
+          <a:ln w="38100">
+            <a:noFill/>
+          </a:ln>
+        </p:spPr>
+        <p:txBody>
+          <a:bodyPr wrap="square" lIns="0" tIns="36576" rIns="0" bIns="36576" rtlCol="0" anchor="ctr">
+            <a:noAutofit/>
+          </a:bodyPr>
+          <a:lstStyle/>
+          <a:p>
+            <a:pPr algn="l" indent="0" marL="0">
+              <a:buNone/>
+            </a:pPr>
             <a:r>
               <a:rPr lang="en-US" sz="2200" dirty="0">
                 <a:solidFill>
@@ -5181,7 +5375,7 @@
                 <a:ea typeface="Lexend Deca" pitchFamily="34" charset="-122"/>
                 <a:cs typeface="Lexend Deca" pitchFamily="34" charset="-120"/>
               </a:rPr>
-              <a:t>?</a:t>
+              <a:t>What</a:t>
             </a:r>
             <a:endParaRPr lang="en-US" sz="2200" dirty="0"/>
           </a:p>
@@ -5189,14 +5383,14 @@
       </p:sp>
       <p:sp>
         <p:nvSpPr>
-          <p:cNvPr id="48" name="Answer bg"/>
-          <p:cNvSpPr/>
-          <p:nvPr/>
-        </p:nvSpPr>
-        <p:spPr>
-          <a:xfrm>
-            <a:off x="6949440" y="4334256"/>
-            <a:ext cx="4526280" cy="786384"/>
+          <p:cNvPr id="75" name="Highlight"/>
+          <p:cNvSpPr/>
+          <p:nvPr/>
+        </p:nvSpPr>
+        <p:spPr>
+          <a:xfrm>
+            <a:off x="4428439" y="5577840"/>
+            <a:ext cx="1306495" cy="530352"/>
           </a:xfrm>
           <a:prstGeom prst="roundRect">
             <a:avLst>
@@ -5204,7 +5398,7 @@
             </a:avLst>
           </a:prstGeom>
           <a:solidFill>
-            <a:srgbClr val="FFFFFF"/>
+            <a:srgbClr val="FFE28C"/>
           </a:solidFill>
           <a:ln w="38100">
             <a:noFill/>
@@ -5236,14 +5430,14 @@
       </p:sp>
       <p:sp>
         <p:nvSpPr>
-          <p:cNvPr id="47" name="Answer"/>
-          <p:cNvSpPr/>
-          <p:nvPr/>
-        </p:nvSpPr>
-        <p:spPr>
-          <a:xfrm>
-            <a:off x="6949440" y="4315968"/>
-            <a:ext cx="4526280" cy="822960"/>
+          <p:cNvPr id="76" name="Helper"/>
+          <p:cNvSpPr/>
+          <p:nvPr/>
+        </p:nvSpPr>
+        <p:spPr>
+          <a:xfrm>
+            <a:off x="4428439" y="5577840"/>
+            <a:ext cx="1306495" cy="530352"/>
           </a:xfrm>
           <a:prstGeom prst="rect">
             <a:avLst/>
@@ -5254,6 +5448,92 @@
           </a:ln>
         </p:spPr>
         <p:txBody>
+          <a:bodyPr wrap="square" lIns="0" tIns="36576" rIns="0" bIns="36576" rtlCol="0" anchor="ctr">
+            <a:noAutofit/>
+          </a:bodyPr>
+          <a:lstStyle/>
+          <a:p>
+            <a:pPr algn="ctr" indent="0" marL="0">
+              <a:buNone/>
+            </a:pPr>
+            <a:r>
+              <a:rPr lang="en-US" sz="2200" dirty="0" b="1">
+                <a:solidFill>
+                  <a:srgbClr val="1B2236"/>
+                </a:solidFill>
+                <a:latin typeface="Lexend Deca" pitchFamily="34" charset="0"/>
+                <a:ea typeface="Lexend Deca" pitchFamily="34" charset="-122"/>
+                <a:cs typeface="Lexend Deca" pitchFamily="34" charset="-120"/>
+              </a:rPr>
+              <a:t>should</a:t>
+            </a:r>
+            <a:endParaRPr lang="en-US" sz="2200" dirty="0"/>
+          </a:p>
+        </p:txBody>
+      </p:sp>
+      <p:sp>
+        <p:nvSpPr>
+          <p:cNvPr id="77" name="Rest"/>
+          <p:cNvSpPr/>
+          <p:nvPr/>
+        </p:nvSpPr>
+        <p:spPr>
+          <a:xfrm>
+            <a:off x="5789798" y="5577840"/>
+            <a:ext cx="1239012" cy="530352"/>
+          </a:xfrm>
+          <a:prstGeom prst="rect">
+            <a:avLst/>
+          </a:prstGeom>
+          <a:noFill/>
+          <a:ln w="38100">
+            <a:noFill/>
+          </a:ln>
+        </p:spPr>
+        <p:txBody>
+          <a:bodyPr wrap="square" lIns="0" tIns="36576" rIns="0" bIns="36576" rtlCol="0" anchor="ctr">
+            <a:noAutofit/>
+          </a:bodyPr>
+          <a:lstStyle/>
+          <a:p>
+            <a:pPr algn="l" indent="0" marL="0">
+              <a:buNone/>
+            </a:pPr>
+            <a:r>
+              <a:rPr lang="en-US" sz="2200" dirty="0">
+                <a:solidFill>
+                  <a:srgbClr val="1B2236"/>
+                </a:solidFill>
+                <a:latin typeface="Lexend Deca" pitchFamily="34" charset="0"/>
+                <a:ea typeface="Lexend Deca" pitchFamily="34" charset="-122"/>
+                <a:cs typeface="Lexend Deca" pitchFamily="34" charset="-120"/>
+              </a:rPr>
+              <a:t>she do?</a:t>
+            </a:r>
+            <a:endParaRPr lang="en-US" sz="2200" dirty="0"/>
+          </a:p>
+        </p:txBody>
+      </p:sp>
+      <p:sp>
+        <p:nvSpPr>
+          <p:cNvPr id="78" name="Card head"/>
+          <p:cNvSpPr/>
+          <p:nvPr/>
+        </p:nvSpPr>
+        <p:spPr>
+          <a:xfrm>
+            <a:off x="8549640" y="1280160"/>
+            <a:ext cx="3017520" cy="548640"/>
+          </a:xfrm>
+          <a:prstGeom prst="rect">
+            <a:avLst/>
+          </a:prstGeom>
+          <a:noFill/>
+          <a:ln w="38100">
+            <a:noFill/>
+          </a:ln>
+        </p:spPr>
+        <p:txBody>
           <a:bodyPr wrap="square" lIns="73152" tIns="36576" rIns="73152" bIns="36576" rtlCol="0" anchor="ctr">
             <a:noAutofit/>
           </a:bodyPr>
@@ -5263,91 +5543,225 @@
               <a:buNone/>
             </a:pPr>
             <a:r>
-              <a:rPr lang="en-US" sz="2200" dirty="0">
-                <a:solidFill>
-                  <a:srgbClr val="1B2236"/>
-                </a:solidFill>
-                <a:latin typeface="Lexend Deca" pitchFamily="34" charset="0"/>
-                <a:ea typeface="Lexend Deca" pitchFamily="34" charset="-122"/>
-                <a:cs typeface="Lexend Deca" pitchFamily="34" charset="-120"/>
-              </a:rPr>
-              <a:t>I </a:t>
-            </a:r>
-            <a:r>
-              <a:rPr lang="en-US" sz="2200" dirty="0" b="1">
-                <a:solidFill>
-                  <a:srgbClr val="1B2236"/>
-                </a:solidFill>
-                <a:latin typeface="Lexend Deca" pitchFamily="34" charset="0"/>
-                <a:ea typeface="Lexend Deca" pitchFamily="34" charset="-122"/>
-                <a:cs typeface="Lexend Deca" pitchFamily="34" charset="-120"/>
-              </a:rPr>
-              <a:t>have</a:t>
-            </a:r>
-            <a:r>
-              <a:rPr lang="en-US" sz="2200" dirty="0">
-                <a:solidFill>
-                  <a:srgbClr val="1B2236"/>
-                </a:solidFill>
-                <a:latin typeface="Lexend Deca" pitchFamily="34" charset="0"/>
-                <a:ea typeface="Lexend Deca" pitchFamily="34" charset="-122"/>
-                <a:cs typeface="Lexend Deca" pitchFamily="34" charset="-120"/>
-              </a:rPr>
-              <a:t> a headache.</a:t>
-            </a:r>
-            <a:endParaRPr lang="en-US" sz="2200" dirty="0"/>
-          </a:p>
+              <a:rPr lang="en-US" sz="2400" dirty="0" b="1">
+                <a:solidFill>
+                  <a:srgbClr val="1B2236"/>
+                </a:solidFill>
+                <a:latin typeface="Lexend Deca" pitchFamily="34" charset="0"/>
+                <a:ea typeface="Lexend Deca" pitchFamily="34" charset="-122"/>
+                <a:cs typeface="Lexend Deca" pitchFamily="34" charset="-120"/>
+              </a:rPr>
+              <a:t>Advice</a:t>
+            </a:r>
+            <a:endParaRPr lang="en-US" sz="2400" dirty="0"/>
+          </a:p>
+        </p:txBody>
+      </p:sp>
+      <p:sp>
+        <p:nvSpPr>
+          <p:cNvPr id="79" name="Card item"/>
+          <p:cNvSpPr/>
+          <p:nvPr/>
+        </p:nvSpPr>
+        <p:spPr>
+          <a:xfrm>
+            <a:off x="8549640" y="1920240"/>
+            <a:ext cx="3017520" cy="457200"/>
+          </a:xfrm>
+          <a:prstGeom prst="rect">
+            <a:avLst/>
+          </a:prstGeom>
+          <a:noFill/>
+          <a:ln w="38100">
+            <a:noFill/>
+          </a:ln>
+        </p:spPr>
+        <p:txBody>
+          <a:bodyPr wrap="square" lIns="73152" tIns="36576" rIns="73152" bIns="36576" rtlCol="0" anchor="ctr">
+            <a:noAutofit/>
+          </a:bodyPr>
+          <a:lstStyle/>
           <a:p>
             <a:pPr algn="l" indent="0" marL="0">
               <a:buNone/>
             </a:pPr>
             <a:r>
-              <a:rPr lang="en-US" sz="2200" dirty="0">
-                <a:solidFill>
-                  <a:srgbClr val="1B2236"/>
-                </a:solidFill>
-                <a:latin typeface="Lexend Deca" pitchFamily="34" charset="0"/>
-                <a:ea typeface="Lexend Deca" pitchFamily="34" charset="-122"/>
-                <a:cs typeface="Lexend Deca" pitchFamily="34" charset="-120"/>
-              </a:rPr>
-              <a:t>My head </a:t>
-            </a:r>
-            <a:r>
-              <a:rPr lang="en-US" sz="2200" dirty="0" b="1">
-                <a:solidFill>
-                  <a:srgbClr val="1B2236"/>
-                </a:solidFill>
-                <a:latin typeface="Lexend Deca" pitchFamily="34" charset="0"/>
-                <a:ea typeface="Lexend Deca" pitchFamily="34" charset="-122"/>
-                <a:cs typeface="Lexend Deca" pitchFamily="34" charset="-120"/>
-              </a:rPr>
-              <a:t>hurts</a:t>
-            </a:r>
-            <a:r>
-              <a:rPr lang="en-US" sz="2200" dirty="0">
-                <a:solidFill>
-                  <a:srgbClr val="1B2236"/>
-                </a:solidFill>
-                <a:latin typeface="Lexend Deca" pitchFamily="34" charset="0"/>
-                <a:ea typeface="Lexend Deca" pitchFamily="34" charset="-122"/>
-                <a:cs typeface="Lexend Deca" pitchFamily="34" charset="-120"/>
-              </a:rPr>
-              <a:t>.</a:t>
-            </a:r>
-            <a:endParaRPr lang="en-US" sz="2200" dirty="0"/>
-          </a:p>
-        </p:txBody>
-      </p:sp>
-      <p:sp>
-        <p:nvSpPr>
-          <p:cNvPr id="49" name="Highlight"/>
-          <p:cNvSpPr/>
-          <p:nvPr/>
-        </p:nvSpPr>
-        <p:spPr>
-          <a:xfrm>
-            <a:off x="1481328" y="5367528"/>
-            <a:ext cx="2281428" cy="548640"/>
+              <a:rPr lang="en-US" sz="2000" dirty="0">
+                <a:solidFill>
+                  <a:srgbClr val="1B2236"/>
+                </a:solidFill>
+                <a:latin typeface="Lexend Deca" pitchFamily="34" charset="0"/>
+                <a:ea typeface="Lexend Deca" pitchFamily="34" charset="-122"/>
+                <a:cs typeface="Lexend Deca" pitchFamily="34" charset="-120"/>
+              </a:rPr>
+              <a:t>You </a:t>
+            </a:r>
+            <a:r>
+              <a:rPr lang="en-US" sz="2000" dirty="0" b="1">
+                <a:solidFill>
+                  <a:srgbClr val="5B3FC4"/>
+                </a:solidFill>
+                <a:latin typeface="Lexend Deca" pitchFamily="34" charset="0"/>
+                <a:ea typeface="Lexend Deca" pitchFamily="34" charset="-122"/>
+                <a:cs typeface="Lexend Deca" pitchFamily="34" charset="-120"/>
+              </a:rPr>
+              <a:t>should</a:t>
+            </a:r>
+            <a:r>
+              <a:rPr lang="en-US" sz="2000" dirty="0">
+                <a:solidFill>
+                  <a:srgbClr val="1B2236"/>
+                </a:solidFill>
+                <a:latin typeface="Lexend Deca" pitchFamily="34" charset="0"/>
+                <a:ea typeface="Lexend Deca" pitchFamily="34" charset="-122"/>
+                <a:cs typeface="Lexend Deca" pitchFamily="34" charset="-120"/>
+              </a:rPr>
+              <a:t> rest.</a:t>
+            </a:r>
+            <a:endParaRPr lang="en-US" sz="2000" dirty="0"/>
+          </a:p>
+        </p:txBody>
+      </p:sp>
+      <p:sp>
+        <p:nvSpPr>
+          <p:cNvPr id="80" name="Card item"/>
+          <p:cNvSpPr/>
+          <p:nvPr/>
+        </p:nvSpPr>
+        <p:spPr>
+          <a:xfrm>
+            <a:off x="8549640" y="2404872"/>
+            <a:ext cx="3017520" cy="777240"/>
+          </a:xfrm>
+          <a:prstGeom prst="rect">
+            <a:avLst/>
+          </a:prstGeom>
+          <a:noFill/>
+          <a:ln w="38100">
+            <a:noFill/>
+          </a:ln>
+        </p:spPr>
+        <p:txBody>
+          <a:bodyPr wrap="square" lIns="73152" tIns="36576" rIns="73152" bIns="36576" rtlCol="0" anchor="ctr">
+            <a:noAutofit/>
+          </a:bodyPr>
+          <a:lstStyle/>
+          <a:p>
+            <a:pPr algn="l" indent="0" marL="0">
+              <a:buNone/>
+            </a:pPr>
+            <a:r>
+              <a:rPr lang="en-US" sz="2000" dirty="0">
+                <a:solidFill>
+                  <a:srgbClr val="1B2236"/>
+                </a:solidFill>
+                <a:latin typeface="Lexend Deca" pitchFamily="34" charset="0"/>
+                <a:ea typeface="Lexend Deca" pitchFamily="34" charset="-122"/>
+                <a:cs typeface="Lexend Deca" pitchFamily="34" charset="-120"/>
+              </a:rPr>
+              <a:t>He </a:t>
+            </a:r>
+            <a:r>
+              <a:rPr lang="en-US" sz="2000" dirty="0" b="1">
+                <a:solidFill>
+                  <a:srgbClr val="5B3FC4"/>
+                </a:solidFill>
+                <a:latin typeface="Lexend Deca" pitchFamily="34" charset="0"/>
+                <a:ea typeface="Lexend Deca" pitchFamily="34" charset="-122"/>
+                <a:cs typeface="Lexend Deca" pitchFamily="34" charset="-120"/>
+              </a:rPr>
+              <a:t>should</a:t>
+            </a:r>
+            <a:r>
+              <a:rPr lang="en-US" sz="2000" dirty="0">
+                <a:solidFill>
+                  <a:srgbClr val="1B2236"/>
+                </a:solidFill>
+                <a:latin typeface="Lexend Deca" pitchFamily="34" charset="0"/>
+                <a:ea typeface="Lexend Deca" pitchFamily="34" charset="-122"/>
+                <a:cs typeface="Lexend Deca" pitchFamily="34" charset="-120"/>
+              </a:rPr>
+              <a:t> see a doctor.</a:t>
+            </a:r>
+            <a:endParaRPr lang="en-US" sz="2000" dirty="0"/>
+          </a:p>
+        </p:txBody>
+      </p:sp>
+      <p:sp>
+        <p:nvSpPr>
+          <p:cNvPr id="81" name="Card item"/>
+          <p:cNvSpPr/>
+          <p:nvPr/>
+        </p:nvSpPr>
+        <p:spPr>
+          <a:xfrm>
+            <a:off x="8549640" y="3209544"/>
+            <a:ext cx="3017520" cy="777240"/>
+          </a:xfrm>
+          <a:prstGeom prst="rect">
+            <a:avLst/>
+          </a:prstGeom>
+          <a:noFill/>
+          <a:ln w="38100">
+            <a:noFill/>
+          </a:ln>
+        </p:spPr>
+        <p:txBody>
+          <a:bodyPr wrap="square" lIns="73152" tIns="36576" rIns="73152" bIns="36576" rtlCol="0" anchor="ctr">
+            <a:noAutofit/>
+          </a:bodyPr>
+          <a:lstStyle/>
+          <a:p>
+            <a:pPr algn="l" indent="0" marL="0">
+              <a:buNone/>
+            </a:pPr>
+            <a:r>
+              <a:rPr lang="en-US" sz="2000" dirty="0">
+                <a:solidFill>
+                  <a:srgbClr val="1B2236"/>
+                </a:solidFill>
+                <a:latin typeface="Lexend Deca" pitchFamily="34" charset="0"/>
+                <a:ea typeface="Lexend Deca" pitchFamily="34" charset="-122"/>
+                <a:cs typeface="Lexend Deca" pitchFamily="34" charset="-120"/>
+              </a:rPr>
+              <a:t>She </a:t>
+            </a:r>
+            <a:r>
+              <a:rPr lang="en-US" sz="2000" dirty="0" b="1">
+                <a:solidFill>
+                  <a:srgbClr val="5B3FC4"/>
+                </a:solidFill>
+                <a:latin typeface="Lexend Deca" pitchFamily="34" charset="0"/>
+                <a:ea typeface="Lexend Deca" pitchFamily="34" charset="-122"/>
+                <a:cs typeface="Lexend Deca" pitchFamily="34" charset="-120"/>
+              </a:rPr>
+              <a:t>shouldn't</a:t>
+            </a:r>
+            <a:r>
+              <a:rPr lang="en-US" sz="2000" dirty="0">
+                <a:solidFill>
+                  <a:srgbClr val="1B2236"/>
+                </a:solidFill>
+                <a:latin typeface="Lexend Deca" pitchFamily="34" charset="0"/>
+                <a:ea typeface="Lexend Deca" pitchFamily="34" charset="-122"/>
+                <a:cs typeface="Lexend Deca" pitchFamily="34" charset="-120"/>
+              </a:rPr>
+              <a:t> go to work.</a:t>
+            </a:r>
+            <a:endParaRPr lang="en-US" sz="2000" dirty="0"/>
+          </a:p>
+        </p:txBody>
+      </p:sp>
+      <p:sp>
+        <p:nvSpPr>
+          <p:cNvPr id="82" name="Example"/>
+          <p:cNvSpPr/>
+          <p:nvPr/>
+        </p:nvSpPr>
+        <p:spPr>
+          <a:xfrm>
+            <a:off x="8549640" y="5394960"/>
+            <a:ext cx="3017520" cy="502920"/>
           </a:xfrm>
           <a:prstGeom prst="roundRect">
             <a:avLst>
@@ -5355,7 +5769,7 @@
             </a:avLst>
           </a:prstGeom>
           <a:solidFill>
-            <a:srgbClr val="FFE28C"/>
+            <a:srgbClr val="FFFFFF"/>
           </a:solidFill>
           <a:ln w="38100">
             <a:noFill/>
@@ -5367,50 +5781,7 @@
           </a:bodyPr>
           <a:lstStyle/>
           <a:p>
-            <a:pPr algn="l" indent="0" marL="0">
-              <a:buNone/>
-            </a:pPr>
-            <a:r>
-              <a:rPr lang="en-US" sz="2000" dirty="0">
-                <a:solidFill>
-                  <a:srgbClr val="1B2236"/>
-                </a:solidFill>
-                <a:latin typeface="Lexend Deca" pitchFamily="34" charset="0"/>
-                <a:ea typeface="Lexend Deca" pitchFamily="34" charset="-122"/>
-                <a:cs typeface="Lexend Deca" pitchFamily="34" charset="-120"/>
-              </a:rPr>
-              <a:t/>
-            </a:r>
-            <a:endParaRPr lang="en-US" sz="2000" dirty="0"/>
-          </a:p>
-        </p:txBody>
-      </p:sp>
-      <p:sp>
-        <p:nvSpPr>
-          <p:cNvPr id="50" name="Question"/>
-          <p:cNvSpPr/>
-          <p:nvPr/>
-        </p:nvSpPr>
-        <p:spPr>
-          <a:xfrm>
-            <a:off x="1481328" y="5230368"/>
-            <a:ext cx="4526280" cy="822960"/>
-          </a:xfrm>
-          <a:prstGeom prst="rect">
-            <a:avLst/>
-          </a:prstGeom>
-          <a:noFill/>
-          <a:ln w="38100">
-            <a:noFill/>
-          </a:ln>
-        </p:spPr>
-        <p:txBody>
-          <a:bodyPr wrap="square" lIns="73152" tIns="36576" rIns="73152" bIns="36576" rtlCol="0" anchor="ctr">
-            <a:noAutofit/>
-          </a:bodyPr>
-          <a:lstStyle/>
-          <a:p>
-            <a:pPr algn="l" indent="0" marL="0">
+            <a:pPr algn="ctr" indent="0" marL="0">
               <a:buNone/>
             </a:pPr>
             <a:r>
@@ -5422,18 +5793,18 @@
                 <a:ea typeface="Lexend Deca" pitchFamily="34" charset="-122"/>
                 <a:cs typeface="Lexend Deca" pitchFamily="34" charset="-120"/>
               </a:rPr>
-              <a:t>What's </a:t>
+              <a:t>No </a:t>
             </a:r>
             <a:r>
               <a:rPr lang="en-US" sz="2200" dirty="0" b="1">
                 <a:solidFill>
-                  <a:srgbClr val="1B2236"/>
-                </a:solidFill>
-                <a:latin typeface="Lexend Deca" pitchFamily="34" charset="0"/>
-                <a:ea typeface="Lexend Deca" pitchFamily="34" charset="-122"/>
-                <a:cs typeface="Lexend Deca" pitchFamily="34" charset="-120"/>
-              </a:rPr>
-              <a:t>wrong</a:t>
+                  <a:srgbClr val="5B3FC4"/>
+                </a:solidFill>
+                <a:latin typeface="Lexend Deca" pitchFamily="34" charset="0"/>
+                <a:ea typeface="Lexend Deca" pitchFamily="34" charset="-122"/>
+                <a:cs typeface="Lexend Deca" pitchFamily="34" charset="-120"/>
+              </a:rPr>
+              <a:t>to</a:t>
             </a:r>
             <a:r>
               <a:rPr lang="en-US" sz="2200" dirty="0">
@@ -5444,147 +5815,18 @@
                 <a:ea typeface="Lexend Deca" pitchFamily="34" charset="-122"/>
                 <a:cs typeface="Lexend Deca" pitchFamily="34" charset="-120"/>
               </a:rPr>
-              <a:t>?</a:t>
-            </a:r>
-            <a:endParaRPr lang="en-US" sz="2200" dirty="0"/>
-          </a:p>
-        </p:txBody>
-      </p:sp>
-      <p:sp>
-        <p:nvSpPr>
-          <p:cNvPr id="52" name="Answer bg"/>
-          <p:cNvSpPr/>
-          <p:nvPr/>
-        </p:nvSpPr>
-        <p:spPr>
-          <a:xfrm>
-            <a:off x="6949440" y="5248656"/>
-            <a:ext cx="4526280" cy="786384"/>
-          </a:xfrm>
-          <a:prstGeom prst="roundRect">
-            <a:avLst>
-              <a:gd name="adj" fmla="val 22000"/>
-            </a:avLst>
-          </a:prstGeom>
-          <a:solidFill>
-            <a:srgbClr val="FFFFFF"/>
-          </a:solidFill>
-          <a:ln w="38100">
-            <a:noFill/>
-          </a:ln>
-        </p:spPr>
-        <p:txBody>
-          <a:bodyPr wrap="square" lIns="73152" tIns="36576" rIns="73152" bIns="36576" rtlCol="0" anchor="ctr">
-            <a:noAutofit/>
-          </a:bodyPr>
-          <a:lstStyle/>
-          <a:p>
-            <a:pPr algn="l" indent="0" marL="0">
-              <a:buNone/>
-            </a:pPr>
-            <a:r>
-              <a:rPr lang="en-US" sz="2000" dirty="0">
-                <a:solidFill>
-                  <a:srgbClr val="1B2236"/>
-                </a:solidFill>
-                <a:latin typeface="Lexend Deca" pitchFamily="34" charset="0"/>
-                <a:ea typeface="Lexend Deca" pitchFamily="34" charset="-122"/>
-                <a:cs typeface="Lexend Deca" pitchFamily="34" charset="-120"/>
-              </a:rPr>
-              <a:t/>
-            </a:r>
-            <a:endParaRPr lang="en-US" sz="2000" dirty="0"/>
-          </a:p>
-        </p:txBody>
-      </p:sp>
-      <p:sp>
-        <p:nvSpPr>
-          <p:cNvPr id="51" name="Answer"/>
-          <p:cNvSpPr/>
-          <p:nvPr/>
-        </p:nvSpPr>
-        <p:spPr>
-          <a:xfrm>
-            <a:off x="6949440" y="5230368"/>
-            <a:ext cx="4526280" cy="822960"/>
-          </a:xfrm>
-          <a:prstGeom prst="rect">
-            <a:avLst/>
-          </a:prstGeom>
-          <a:noFill/>
-          <a:ln w="38100">
-            <a:noFill/>
-          </a:ln>
-        </p:spPr>
-        <p:txBody>
-          <a:bodyPr wrap="square" lIns="73152" tIns="36576" rIns="73152" bIns="36576" rtlCol="0" anchor="ctr">
-            <a:noAutofit/>
-          </a:bodyPr>
-          <a:lstStyle/>
-          <a:p>
-            <a:pPr algn="l" indent="0" marL="0">
-              <a:buNone/>
-            </a:pPr>
-            <a:r>
-              <a:rPr lang="en-US" sz="2200" dirty="0">
-                <a:solidFill>
-                  <a:srgbClr val="1B2236"/>
-                </a:solidFill>
-                <a:latin typeface="Lexend Deca" pitchFamily="34" charset="0"/>
-                <a:ea typeface="Lexend Deca" pitchFamily="34" charset="-122"/>
-                <a:cs typeface="Lexend Deca" pitchFamily="34" charset="-120"/>
-              </a:rPr>
-              <a:t>I </a:t>
+              <a:t>. No </a:t>
             </a:r>
             <a:r>
               <a:rPr lang="en-US" sz="2200" dirty="0" b="1">
                 <a:solidFill>
-                  <a:srgbClr val="1B2236"/>
-                </a:solidFill>
-                <a:latin typeface="Lexend Deca" pitchFamily="34" charset="0"/>
-                <a:ea typeface="Lexend Deca" pitchFamily="34" charset="-122"/>
-                <a:cs typeface="Lexend Deca" pitchFamily="34" charset="-120"/>
-              </a:rPr>
-              <a:t>have</a:t>
-            </a:r>
-            <a:r>
-              <a:rPr lang="en-US" sz="2200" dirty="0">
-                <a:solidFill>
-                  <a:srgbClr val="1B2236"/>
-                </a:solidFill>
-                <a:latin typeface="Lexend Deca" pitchFamily="34" charset="0"/>
-                <a:ea typeface="Lexend Deca" pitchFamily="34" charset="-122"/>
-                <a:cs typeface="Lexend Deca" pitchFamily="34" charset="-120"/>
-              </a:rPr>
-              <a:t> a cold.</a:t>
-            </a:r>
-            <a:endParaRPr lang="en-US" sz="2200" dirty="0"/>
-          </a:p>
-          <a:p>
-            <a:pPr algn="l" indent="0" marL="0">
-              <a:buNone/>
-            </a:pPr>
-            <a:r>
-              <a:rPr lang="en-US" sz="2200" dirty="0">
-                <a:solidFill>
-                  <a:srgbClr val="1B2236"/>
-                </a:solidFill>
-                <a:latin typeface="Lexend Deca" pitchFamily="34" charset="0"/>
-                <a:ea typeface="Lexend Deca" pitchFamily="34" charset="-122"/>
-                <a:cs typeface="Lexend Deca" pitchFamily="34" charset="-120"/>
-              </a:rPr>
-              <a:t>My feet </a:t>
-            </a:r>
-            <a:r>
-              <a:rPr lang="en-US" sz="2200" dirty="0" b="1">
-                <a:solidFill>
-                  <a:srgbClr val="1B2236"/>
-                </a:solidFill>
-                <a:latin typeface="Lexend Deca" pitchFamily="34" charset="0"/>
-                <a:ea typeface="Lexend Deca" pitchFamily="34" charset="-122"/>
-                <a:cs typeface="Lexend Deca" pitchFamily="34" charset="-120"/>
-              </a:rPr>
-              <a:t>hurt</a:t>
+                  <a:srgbClr val="5B3FC4"/>
+                </a:solidFill>
+                <a:latin typeface="Lexend Deca" pitchFamily="34" charset="0"/>
+                <a:ea typeface="Lexend Deca" pitchFamily="34" charset="-122"/>
+                <a:cs typeface="Lexend Deca" pitchFamily="34" charset="-120"/>
+              </a:rPr>
+              <a:t>-s</a:t>
             </a:r>
             <a:r>
               <a:rPr lang="en-US" sz="2200" dirty="0">
@@ -5640,7 +5882,7 @@
                                           </p:stCondLst>
                                         </p:cTn>
                                         <p:tgtEl>
-                                          <p:spTgt spid="45"/>
+                                          <p:spTgt spid="67"/>
                                         </p:tgtEl>
                                         <p:attrNameLst>
                                           <p:attrName>style.visibility</p:attrName>
@@ -5654,42 +5896,7 @@
                                       <p:cBhvr>
                                         <p:cTn id="7" dur="400"/>
                                         <p:tgtEl>
-                                          <p:spTgt spid="45"/>
-                                        </p:tgtEl>
-                                      </p:cBhvr>
-                                    </p:animEffect>
-                                  </p:childTnLst>
-                                </p:cTn>
-                              </p:par>
-                              <p:par>
-                                <p:cTn id="8" presetID="10" presetClass="entr" presetSubtype="0" fill="hold" nodeType="withEffect">
-                                  <p:stCondLst>
-                                    <p:cond delay="0"/>
-                                  </p:stCondLst>
-                                  <p:childTnLst>
-                                    <p:set>
-                                      <p:cBhvr>
-                                        <p:cTn id="9" dur="1" fill="hold">
-                                          <p:stCondLst>
-                                            <p:cond delay="0"/>
-                                          </p:stCondLst>
-                                        </p:cTn>
-                                        <p:tgtEl>
-                                          <p:spTgt spid="48"/>
-                                        </p:tgtEl>
-                                        <p:attrNameLst>
-                                          <p:attrName>style.visibility</p:attrName>
-                                        </p:attrNameLst>
-                                      </p:cBhvr>
-                                      <p:to>
-                                        <p:strVal val="visible"/>
-                                      </p:to>
-                                    </p:set>
-                                    <p:animEffect transition="in" filter="fade">
-                                      <p:cBhvr>
-                                        <p:cTn id="10" dur="400"/>
-                                        <p:tgtEl>
-                                          <p:spTgt spid="48"/>
+                                          <p:spTgt spid="67"/>
                                         </p:tgtEl>
                                       </p:cBhvr>
                                     </p:animEffect>
@@ -5703,32 +5910,32 @@
                     </p:cTn>
                   </p:par>
                   <p:par>
-                    <p:cTn id="11" fill="hold">
+                    <p:cTn id="8" fill="hold">
                       <p:stCondLst>
                         <p:cond delay="indefinite"/>
                       </p:stCondLst>
                       <p:childTnLst>
                         <p:par>
-                          <p:cTn id="12" fill="hold">
+                          <p:cTn id="9" fill="hold">
                             <p:stCondLst>
                               <p:cond delay="0"/>
                             </p:stCondLst>
                             <p:childTnLst>
                               <p:par>
-                                <p:cTn id="13" presetID="10" presetClass="entr" presetSubtype="0" fill="hold" nodeType="clickEffect">
+                                <p:cTn id="10" presetID="10" presetClass="entr" presetSubtype="0" fill="hold" nodeType="clickEffect">
                                   <p:stCondLst>
                                     <p:cond delay="0"/>
                                   </p:stCondLst>
                                   <p:childTnLst>
                                     <p:set>
                                       <p:cBhvr>
-                                        <p:cTn id="14" dur="1" fill="hold">
+                                        <p:cTn id="11" dur="1" fill="hold">
                                           <p:stCondLst>
                                             <p:cond delay="0"/>
                                           </p:stCondLst>
                                         </p:cTn>
                                         <p:tgtEl>
-                                          <p:spTgt spid="49"/>
+                                          <p:spTgt spid="71"/>
                                         </p:tgtEl>
                                         <p:attrNameLst>
                                           <p:attrName>style.visibility</p:attrName>
@@ -5740,30 +5947,48 @@
                                     </p:set>
                                     <p:animEffect transition="in" filter="fade">
                                       <p:cBhvr>
-                                        <p:cTn id="15" dur="400"/>
+                                        <p:cTn id="12" dur="400"/>
                                         <p:tgtEl>
-                                          <p:spTgt spid="49"/>
+                                          <p:spTgt spid="71"/>
                                         </p:tgtEl>
                                       </p:cBhvr>
                                     </p:animEffect>
                                   </p:childTnLst>
                                 </p:cTn>
                               </p:par>
+                            </p:childTnLst>
+                          </p:cTn>
+                        </p:par>
+                      </p:childTnLst>
+                    </p:cTn>
+                  </p:par>
+                  <p:par>
+                    <p:cTn id="13" fill="hold">
+                      <p:stCondLst>
+                        <p:cond delay="indefinite"/>
+                      </p:stCondLst>
+                      <p:childTnLst>
+                        <p:par>
+                          <p:cTn id="14" fill="hold">
+                            <p:stCondLst>
+                              <p:cond delay="0"/>
+                            </p:stCondLst>
+                            <p:childTnLst>
                               <p:par>
-                                <p:cTn id="16" presetID="10" presetClass="entr" presetSubtype="0" fill="hold" nodeType="withEffect">
+                                <p:cTn id="15" presetID="10" presetClass="entr" presetSubtype="0" fill="hold" nodeType="clickEffect">
                                   <p:stCondLst>
                                     <p:cond delay="0"/>
                                   </p:stCondLst>
                                   <p:childTnLst>
                                     <p:set>
                                       <p:cBhvr>
-                                        <p:cTn id="17" dur="1" fill="hold">
+                                        <p:cTn id="16" dur="1" fill="hold">
                                           <p:stCondLst>
                                             <p:cond delay="0"/>
                                           </p:stCondLst>
                                         </p:cTn>
                                         <p:tgtEl>
-                                          <p:spTgt spid="52"/>
+                                          <p:spTgt spid="75"/>
                                         </p:tgtEl>
                                         <p:attrNameLst>
                                           <p:attrName>style.visibility</p:attrName>
@@ -5775,9 +6000,9 @@
                                     </p:set>
                                     <p:animEffect transition="in" filter="fade">
                                       <p:cBhvr>
-                                        <p:cTn id="18" dur="400"/>
+                                        <p:cTn id="17" dur="400"/>
                                         <p:tgtEl>
-                                          <p:spTgt spid="52"/>
+                                          <p:spTgt spid="75"/>
                                         </p:tgtEl>
                                       </p:cBhvr>
                                     </p:animEffect>
@@ -20979,7 +21204,7 @@
 
 <file path=ppt/slides/slide9.xml><?xml version="1.0" encoding="utf-8"?>
 <p:sld xmlns:a="http://schemas.openxmlformats.org/drawingml/2006/main" xmlns:r="http://schemas.openxmlformats.org/officeDocument/2006/relationships" xmlns:p="http://schemas.openxmlformats.org/presentationml/2006/main">
-  <p:cSld name="Slide 9">
+  <p:cSld name="Slide 4">
     <p:bg>
       <p:bgPr>
         <a:solidFill>
@@ -21009,32 +21234,8 @@
         </p:nvSpPr>
         <p:spPr>
           <a:xfrm>
-            <a:off x="0" y="0"/>
-            <a:ext cx="3063240" cy="6858000"/>
-          </a:xfrm>
-          <a:prstGeom prst="rect">
-            <a:avLst/>
-          </a:prstGeom>
-          <a:solidFill>
-            <a:srgbClr val="B9D2F7"/>
-          </a:solidFill>
-          <a:ln/>
-        </p:spPr>
-        <p:txBody>
-          <a:bodyPr/>
-          <a:p/>
-        </p:txBody>
-      </p:sp>
-      <p:sp>
-        <p:nvSpPr>
-          <p:cNvPr id="4" name="Shape 2"/>
-          <p:cNvSpPr/>
-          <p:nvPr/>
-        </p:nvSpPr>
-        <p:spPr>
-          <a:xfrm>
-            <a:off x="8156448" y="1289304"/>
-            <a:ext cx="3429000" cy="4983480"/>
+            <a:off x="6742786" y="3649370"/>
+            <a:ext cx="4912157" cy="2561234"/>
           </a:xfrm>
           <a:prstGeom prst="round1Rect">
             <a:avLst>
@@ -21042,9 +21243,14 @@
             </a:avLst>
           </a:prstGeom>
           <a:solidFill>
-            <a:srgbClr val="8FAFE3"/>
-          </a:solidFill>
-          <a:ln/>
+            <a:srgbClr val="B9D2F7"/>
+          </a:solidFill>
+          <a:ln w="76200">
+            <a:solidFill>
+              <a:srgbClr val="FFFFFF"/>
+            </a:solidFill>
+            <a:prstDash val="solid"/>
+          </a:ln>
         </p:spPr>
         <p:txBody>
           <a:bodyPr/>
@@ -21059,8 +21265,133 @@
         </p:nvSpPr>
         <p:spPr>
           <a:xfrm>
-            <a:off x="8321040" y="1097280"/>
-            <a:ext cx="3429000" cy="4983480"/>
+            <a:off x="560116" y="1350752"/>
+            <a:ext cx="5663794" cy="1566367"/>
+          </a:xfrm>
+          <a:prstGeom prst="roundRect">
+            <a:avLst>
+              <a:gd name="adj" fmla="val 16667"/>
+            </a:avLst>
+          </a:prstGeom>
+          <a:solidFill>
+            <a:srgbClr val="8FAFE3"/>
+          </a:solidFill>
+          <a:ln/>
+        </p:spPr>
+        <p:txBody>
+          <a:bodyPr/>
+          <a:p/>
+        </p:txBody>
+      </p:sp>
+      <p:sp>
+        <p:nvSpPr>
+          <p:cNvPr id="6" name="Shape 4"/>
+          <p:cNvSpPr/>
+          <p:nvPr/>
+        </p:nvSpPr>
+        <p:spPr>
+          <a:xfrm>
+            <a:off x="593446" y="1286561"/>
+            <a:ext cx="5663794" cy="1566367"/>
+          </a:xfrm>
+          <a:prstGeom prst="roundRect">
+            <a:avLst>
+              <a:gd name="adj" fmla="val 16667"/>
+            </a:avLst>
+          </a:prstGeom>
+          <a:solidFill>
+            <a:srgbClr val="FFFFFF"/>
+          </a:solidFill>
+          <a:ln/>
+        </p:spPr>
+        <p:txBody>
+          <a:bodyPr/>
+          <a:p/>
+        </p:txBody>
+      </p:sp>
+      <p:sp>
+        <p:nvSpPr>
+          <p:cNvPr id="7" name="Text 5"/>
+          <p:cNvSpPr/>
+          <p:nvPr/>
+        </p:nvSpPr>
+        <p:spPr>
+          <a:xfrm>
+            <a:off x="832104" y="1371600"/>
+            <a:ext cx="5257800" cy="1417320"/>
+          </a:xfrm>
+          <a:prstGeom prst="rect">
+            <a:avLst/>
+          </a:prstGeom>
+          <a:noFill/>
+          <a:ln/>
+        </p:spPr>
+        <p:txBody>
+          <a:bodyPr wrap="square" rtlCol="0" anchor="ctr"/>
+          <a:lstStyle/>
+          <a:p>
+            <a:pPr algn="l" indent="0" marL="0">
+              <a:buNone/>
+            </a:pPr>
+            <a:r>
+              <a:rPr lang="en-US" sz="2000" dirty="0" b="1">
+                <a:solidFill>
+                  <a:srgbClr val="5B3FC4"/>
+                </a:solidFill>
+                <a:latin typeface="Lexend Deca" pitchFamily="34" charset="0"/>
+                <a:ea typeface="Lexend Deca" pitchFamily="34" charset="-122"/>
+                <a:cs typeface="Lexend Deca" pitchFamily="34" charset="-120"/>
+              </a:rPr>
+              <a:t>Grammar Box 1</a:t>
+            </a:r>
+            <a:endParaRPr lang="en-US" sz="2000" dirty="0"/>
+          </a:p>
+          <a:p>
+            <a:pPr algn="l" indent="0" marL="0">
+              <a:buNone/>
+            </a:pPr>
+            <a:r>
+              <a:rPr lang="en-US" sz="3200" dirty="0" b="1">
+                <a:solidFill>
+                  <a:srgbClr val="1B2236"/>
+                </a:solidFill>
+                <a:latin typeface="Lexend Deca" pitchFamily="34" charset="0"/>
+                <a:ea typeface="Lexend Deca" pitchFamily="34" charset="-122"/>
+                <a:cs typeface="Lexend Deca" pitchFamily="34" charset="-120"/>
+              </a:rPr>
+              <a:t>What's the</a:t>
+            </a:r>
+            <a:endParaRPr lang="en-US" sz="3200" dirty="0"/>
+          </a:p>
+          <a:p>
+            <a:pPr algn="l" indent="0" marL="0">
+              <a:buNone/>
+            </a:pPr>
+            <a:r>
+              <a:rPr lang="en-US" sz="3200" dirty="0" b="1">
+                <a:solidFill>
+                  <a:srgbClr val="1B2236"/>
+                </a:solidFill>
+                <a:latin typeface="Lexend Deca" pitchFamily="34" charset="0"/>
+                <a:ea typeface="Lexend Deca" pitchFamily="34" charset="-122"/>
+                <a:cs typeface="Lexend Deca" pitchFamily="34" charset="-120"/>
+              </a:rPr>
+              <a:t>Matter?</a:t>
+            </a:r>
+            <a:endParaRPr lang="en-US" sz="3200" dirty="0"/>
+          </a:p>
+        </p:txBody>
+      </p:sp>
+      <p:sp>
+        <p:nvSpPr>
+          <p:cNvPr id="8" name="Shape 6"/>
+          <p:cNvSpPr/>
+          <p:nvPr/>
+        </p:nvSpPr>
+        <p:spPr>
+          <a:xfrm>
+            <a:off x="1305763" y="3649370"/>
+            <a:ext cx="4790542" cy="2599639"/>
           </a:xfrm>
           <a:prstGeom prst="round1Rect">
             <a:avLst>
@@ -21068,9 +21399,14 @@
             </a:avLst>
           </a:prstGeom>
           <a:solidFill>
-            <a:srgbClr val="B9D2F7"/>
-          </a:solidFill>
-          <a:ln/>
+            <a:srgbClr val="FFFFFF"/>
+          </a:solidFill>
+          <a:ln w="25400">
+            <a:solidFill>
+              <a:srgbClr val="8FAFE3"/>
+            </a:solidFill>
+            <a:prstDash val="solid"/>
+          </a:ln>
         </p:spPr>
         <p:txBody>
           <a:bodyPr/>
@@ -21079,19 +21415,17 @@
       </p:sp>
       <p:sp>
         <p:nvSpPr>
-          <p:cNvPr id="6" name="Shape 4"/>
-          <p:cNvSpPr/>
-          <p:nvPr/>
-        </p:nvSpPr>
-        <p:spPr>
-          <a:xfrm>
-            <a:off x="3394847" y="1032586"/>
-            <a:ext cx="4424782" cy="1863547"/>
-          </a:xfrm>
-          <a:prstGeom prst="roundRect">
-            <a:avLst>
-              <a:gd name="adj" fmla="val 16667"/>
-            </a:avLst>
+          <p:cNvPr id="15" name="Shape 13"/>
+          <p:cNvSpPr/>
+          <p:nvPr/>
+        </p:nvSpPr>
+        <p:spPr>
+          <a:xfrm>
+            <a:off x="741578" y="3253435"/>
+            <a:ext cx="1024128" cy="967435"/>
+          </a:xfrm>
+          <a:prstGeom prst="star10">
+            <a:avLst/>
           </a:prstGeom>
           <a:solidFill>
             <a:srgbClr val="8FAFE3"/>
@@ -21105,22 +21439,20 @@
       </p:sp>
       <p:sp>
         <p:nvSpPr>
-          <p:cNvPr id="7" name="Shape 5"/>
-          <p:cNvSpPr/>
-          <p:nvPr/>
-        </p:nvSpPr>
-        <p:spPr>
-          <a:xfrm>
-            <a:off x="3420770" y="956462"/>
-            <a:ext cx="4424782" cy="1863547"/>
-          </a:xfrm>
-          <a:prstGeom prst="roundRect">
-            <a:avLst>
-              <a:gd name="adj" fmla="val 16667"/>
-            </a:avLst>
-          </a:prstGeom>
-          <a:solidFill>
-            <a:srgbClr val="FFFFFF"/>
+          <p:cNvPr id="16" name="Shape 14"/>
+          <p:cNvSpPr/>
+          <p:nvPr/>
+        </p:nvSpPr>
+        <p:spPr>
+          <a:xfrm>
+            <a:off x="823874" y="3240634"/>
+            <a:ext cx="1042416" cy="1042416"/>
+          </a:xfrm>
+          <a:prstGeom prst="star10">
+            <a:avLst/>
+          </a:prstGeom>
+          <a:solidFill>
+            <a:srgbClr val="FFE28C"/>
           </a:solidFill>
           <a:ln/>
         </p:spPr>
@@ -21131,135 +21463,31 @@
       </p:sp>
       <p:sp>
         <p:nvSpPr>
-          <p:cNvPr id="8" name="Text 6"/>
-          <p:cNvSpPr/>
-          <p:nvPr/>
-        </p:nvSpPr>
-        <p:spPr>
-          <a:xfrm>
-            <a:off x="3566160" y="1078992"/>
-            <a:ext cx="4114800" cy="749808"/>
-          </a:xfrm>
-          <a:prstGeom prst="rect">
-            <a:avLst/>
-          </a:prstGeom>
-          <a:noFill/>
+          <p:cNvPr id="17" name="Shape 15"/>
+          <p:cNvSpPr/>
+          <p:nvPr/>
+        </p:nvSpPr>
+        <p:spPr>
+          <a:xfrm rot="900000">
+            <a:off x="1107338" y="3539642"/>
+            <a:ext cx="445313" cy="445313"/>
+          </a:xfrm>
+          <a:prstGeom prst="mathPlus">
+            <a:avLst/>
+          </a:prstGeom>
+          <a:solidFill>
+            <a:srgbClr val="1B2236"/>
+          </a:solidFill>
           <a:ln/>
         </p:spPr>
         <p:txBody>
-          <a:bodyPr wrap="square" rtlCol="0" anchor="ctr"/>
-          <a:lstStyle/>
-          <a:p>
-            <a:pPr algn="l" indent="0" marL="0">
-              <a:buNone/>
-            </a:pPr>
-            <a:r>
-              <a:rPr lang="en-US" sz="4400" dirty="0" b="1">
-                <a:solidFill>
-                  <a:srgbClr val="1B2236"/>
-                </a:solidFill>
-                <a:latin typeface="Lexend Deca" pitchFamily="34" charset="0"/>
-                <a:ea typeface="Lexend Deca" pitchFamily="34" charset="-122"/>
-                <a:cs typeface="Lexend Deca" pitchFamily="34" charset="-120"/>
-              </a:rPr>
-              <a:t>What should</a:t>
-            </a:r>
-            <a:endParaRPr lang="en-US" sz="4400" dirty="0"/>
-          </a:p>
-        </p:txBody>
-      </p:sp>
-      <p:sp>
-        <p:nvSpPr>
-          <p:cNvPr id="9" name="Text 7"/>
-          <p:cNvSpPr/>
-          <p:nvPr/>
-        </p:nvSpPr>
-        <p:spPr>
-          <a:xfrm>
-            <a:off x="3566160" y="1828800"/>
-            <a:ext cx="4114800" cy="822960"/>
-          </a:xfrm>
-          <a:prstGeom prst="rect">
-            <a:avLst/>
-          </a:prstGeom>
-          <a:noFill/>
-          <a:ln/>
-        </p:spPr>
-        <p:txBody>
-          <a:bodyPr wrap="square" rtlCol="0" anchor="ctr"/>
-          <a:lstStyle/>
-          <a:p>
-            <a:pPr algn="l" indent="0" marL="0">
-              <a:buNone/>
-            </a:pPr>
-            <a:r>
-              <a:rPr lang="en-US" sz="4400" dirty="0" b="1">
-                <a:solidFill>
-                  <a:srgbClr val="1B2236"/>
-                </a:solidFill>
-                <a:latin typeface="Lexend Deca" pitchFamily="34" charset="0"/>
-                <a:ea typeface="Lexend Deca" pitchFamily="34" charset="-122"/>
-                <a:cs typeface="Lexend Deca" pitchFamily="34" charset="-120"/>
-              </a:rPr>
-              <a:t>I do?</a:t>
-            </a:r>
-            <a:endParaRPr lang="en-US" sz="4400" dirty="0"/>
-          </a:p>
-        </p:txBody>
-      </p:sp>
-      <p:sp>
-        <p:nvSpPr>
-          <p:cNvPr id="10" name="Text 8"/>
-          <p:cNvSpPr/>
-          <p:nvPr/>
-        </p:nvSpPr>
-        <p:spPr>
-          <a:xfrm>
-            <a:off x="3487522" y="3108960"/>
-            <a:ext cx="4206240" cy="868680"/>
-          </a:xfrm>
-          <a:prstGeom prst="rect">
-            <a:avLst/>
-          </a:prstGeom>
-          <a:noFill/>
-          <a:ln/>
-        </p:spPr>
-        <p:txBody>
-          <a:bodyPr wrap="square" lIns="0" tIns="0" rIns="0" bIns="0" rtlCol="0" anchor="ctr"/>
-          <a:lstStyle/>
-          <a:p>
-            <a:pPr algn="l" indent="0" marL="0">
-              <a:buNone/>
-            </a:pPr>
-            <a:r>
-              <a:rPr lang="en-US" sz="2000" dirty="0">
-                <a:solidFill>
-                  <a:srgbClr val="1B2236"/>
-                </a:solidFill>
-                <a:latin typeface="Lexend Deca" pitchFamily="34" charset="0"/>
-                <a:ea typeface="Lexend Deca" pitchFamily="34" charset="-122"/>
-                <a:cs typeface="Lexend Deca" pitchFamily="34" charset="-120"/>
-              </a:rPr>
-              <a:t>should + </a:t>
-            </a:r>
-            <a:r>
-              <a:rPr lang="en-US" sz="2000" dirty="0" b="1">
-                <a:solidFill>
-                  <a:srgbClr val="5B3FC4"/>
-                </a:solidFill>
-                <a:latin typeface="Lexend Deca" pitchFamily="34" charset="0"/>
-                <a:ea typeface="Lexend Deca" pitchFamily="34" charset="-122"/>
-                <a:cs typeface="Lexend Deca" pitchFamily="34" charset="-120"/>
-              </a:rPr>
-              <a:t>base verb</a:t>
-            </a:r>
-            <a:endParaRPr lang="en-US" sz="2000" dirty="0"/>
-          </a:p>
+          <a:bodyPr/>
+          <a:p/>
         </p:txBody>
       </p:sp>
       <p:pic>
         <p:nvPicPr>
-          <p:cNvPr id="65" name="Picture 65" descr="L10_rest.png"/>
+          <p:cNvPr id="42" name="Picture 42" descr="L10_headache.png"/>
           <p:cNvPicPr>
             <a:picLocks noChangeAspect="1"/>
           </p:cNvPicPr>
@@ -21273,8 +21501,8 @@
         </p:blipFill>
         <p:spPr>
           <a:xfrm>
-            <a:off x="160020" y="2423160"/>
-            <a:ext cx="2743200" cy="1920240"/>
+            <a:off x="7598664" y="1216152"/>
+            <a:ext cx="3254350" cy="2278045"/>
           </a:xfrm>
           <a:prstGeom prst="rect">
             <a:avLst/>
@@ -21283,14 +21511,14 @@
       </p:pic>
       <p:sp>
         <p:nvSpPr>
-          <p:cNvPr id="66" name="Wh"/>
-          <p:cNvSpPr/>
-          <p:nvPr/>
-        </p:nvSpPr>
-        <p:spPr>
-          <a:xfrm>
-            <a:off x="3520440" y="4114800"/>
-            <a:ext cx="907999" cy="530352"/>
+          <p:cNvPr id="43" name="Q head"/>
+          <p:cNvSpPr/>
+          <p:nvPr/>
+        </p:nvSpPr>
+        <p:spPr>
+          <a:xfrm>
+            <a:off x="1920240" y="3794760"/>
+            <a:ext cx="4023360" cy="457200"/>
           </a:xfrm>
           <a:prstGeom prst="rect">
             <a:avLst/>
@@ -21301,7 +21529,7 @@
           </a:ln>
         </p:spPr>
         <p:txBody>
-          <a:bodyPr wrap="square" lIns="0" tIns="36576" rIns="0" bIns="36576" rtlCol="0" anchor="ctr">
+          <a:bodyPr wrap="square" lIns="73152" tIns="36576" rIns="73152" bIns="36576" rtlCol="0" anchor="ctr">
             <a:noAutofit/>
           </a:bodyPr>
           <a:lstStyle/>
@@ -21310,30 +21538,73 @@
               <a:buNone/>
             </a:pPr>
             <a:r>
-              <a:rPr lang="en-US" sz="2200" dirty="0">
-                <a:solidFill>
-                  <a:srgbClr val="1B2236"/>
-                </a:solidFill>
-                <a:latin typeface="Lexend Deca" pitchFamily="34" charset="0"/>
-                <a:ea typeface="Lexend Deca" pitchFamily="34" charset="-122"/>
-                <a:cs typeface="Lexend Deca" pitchFamily="34" charset="-120"/>
-              </a:rPr>
-              <a:t>What</a:t>
-            </a:r>
-            <a:endParaRPr lang="en-US" sz="2200" dirty="0"/>
-          </a:p>
-        </p:txBody>
-      </p:sp>
-      <p:sp>
-        <p:nvSpPr>
-          <p:cNvPr id="67" name="Highlight"/>
-          <p:cNvSpPr/>
-          <p:nvPr/>
-        </p:nvSpPr>
-        <p:spPr>
-          <a:xfrm>
-            <a:off x="4428439" y="4114800"/>
-            <a:ext cx="1306495" cy="530352"/>
+              <a:rPr lang="en-US" sz="2000" dirty="0" b="1">
+                <a:solidFill>
+                  <a:srgbClr val="5B3FC4"/>
+                </a:solidFill>
+                <a:latin typeface="Lexend Deca" pitchFamily="34" charset="0"/>
+                <a:ea typeface="Lexend Deca" pitchFamily="34" charset="-122"/>
+                <a:cs typeface="Lexend Deca" pitchFamily="34" charset="-120"/>
+              </a:rPr>
+              <a:t>QUESTION</a:t>
+            </a:r>
+            <a:endParaRPr lang="en-US" sz="2000" dirty="0"/>
+          </a:p>
+        </p:txBody>
+      </p:sp>
+      <p:sp>
+        <p:nvSpPr>
+          <p:cNvPr id="44" name="A head"/>
+          <p:cNvSpPr/>
+          <p:nvPr/>
+        </p:nvSpPr>
+        <p:spPr>
+          <a:xfrm>
+            <a:off x="7040880" y="3794760"/>
+            <a:ext cx="4480560" cy="457200"/>
+          </a:xfrm>
+          <a:prstGeom prst="rect">
+            <a:avLst/>
+          </a:prstGeom>
+          <a:noFill/>
+          <a:ln w="38100">
+            <a:noFill/>
+          </a:ln>
+        </p:spPr>
+        <p:txBody>
+          <a:bodyPr wrap="square" lIns="73152" tIns="36576" rIns="73152" bIns="36576" rtlCol="0" anchor="ctr">
+            <a:noAutofit/>
+          </a:bodyPr>
+          <a:lstStyle/>
+          <a:p>
+            <a:pPr algn="l" indent="0" marL="0">
+              <a:buNone/>
+            </a:pPr>
+            <a:r>
+              <a:rPr lang="en-US" sz="2000" dirty="0" b="1">
+                <a:solidFill>
+                  <a:srgbClr val="5B3FC4"/>
+                </a:solidFill>
+                <a:latin typeface="Lexend Deca" pitchFamily="34" charset="0"/>
+                <a:ea typeface="Lexend Deca" pitchFamily="34" charset="-122"/>
+                <a:cs typeface="Lexend Deca" pitchFamily="34" charset="-120"/>
+              </a:rPr>
+              <a:t>ANSWER</a:t>
+            </a:r>
+            <a:endParaRPr lang="en-US" sz="2000" dirty="0"/>
+          </a:p>
+        </p:txBody>
+      </p:sp>
+      <p:sp>
+        <p:nvSpPr>
+          <p:cNvPr id="45" name="Highlight"/>
+          <p:cNvSpPr/>
+          <p:nvPr/>
+        </p:nvSpPr>
+        <p:spPr>
+          <a:xfrm>
+            <a:off x="1481328" y="4453128"/>
+            <a:ext cx="3035808" cy="548640"/>
           </a:xfrm>
           <a:prstGeom prst="roundRect">
             <a:avLst>
@@ -21373,14 +21644,14 @@
       </p:sp>
       <p:sp>
         <p:nvSpPr>
-          <p:cNvPr id="68" name="Helper"/>
-          <p:cNvSpPr/>
-          <p:nvPr/>
-        </p:nvSpPr>
-        <p:spPr>
-          <a:xfrm>
-            <a:off x="4428439" y="4114800"/>
-            <a:ext cx="1306495" cy="530352"/>
+          <p:cNvPr id="46" name="Question"/>
+          <p:cNvSpPr/>
+          <p:nvPr/>
+        </p:nvSpPr>
+        <p:spPr>
+          <a:xfrm>
+            <a:off x="1481328" y="4315968"/>
+            <a:ext cx="4526280" cy="822960"/>
           </a:xfrm>
           <a:prstGeom prst="rect">
             <a:avLst/>
@@ -21391,14 +21662,25 @@
           </a:ln>
         </p:spPr>
         <p:txBody>
-          <a:bodyPr wrap="square" lIns="0" tIns="36576" rIns="0" bIns="36576" rtlCol="0" anchor="ctr">
+          <a:bodyPr wrap="square" lIns="73152" tIns="36576" rIns="73152" bIns="36576" rtlCol="0" anchor="ctr">
             <a:noAutofit/>
           </a:bodyPr>
           <a:lstStyle/>
           <a:p>
-            <a:pPr algn="ctr" indent="0" marL="0">
-              <a:buNone/>
-            </a:pPr>
+            <a:pPr algn="l" indent="0" marL="0">
+              <a:buNone/>
+            </a:pPr>
+            <a:r>
+              <a:rPr lang="en-US" sz="2200" dirty="0">
+                <a:solidFill>
+                  <a:srgbClr val="1B2236"/>
+                </a:solidFill>
+                <a:latin typeface="Lexend Deca" pitchFamily="34" charset="0"/>
+                <a:ea typeface="Lexend Deca" pitchFamily="34" charset="-122"/>
+                <a:cs typeface="Lexend Deca" pitchFamily="34" charset="-120"/>
+              </a:rPr>
+              <a:t>What's </a:t>
+            </a:r>
             <a:r>
               <a:rPr lang="en-US" sz="2200" dirty="0" b="1">
                 <a:solidFill>
@@ -21408,7 +21690,18 @@
                 <a:ea typeface="Lexend Deca" pitchFamily="34" charset="-122"/>
                 <a:cs typeface="Lexend Deca" pitchFamily="34" charset="-120"/>
               </a:rPr>
-              <a:t>should</a:t>
+              <a:t>the matter</a:t>
+            </a:r>
+            <a:r>
+              <a:rPr lang="en-US" sz="2200" dirty="0">
+                <a:solidFill>
+                  <a:srgbClr val="1B2236"/>
+                </a:solidFill>
+                <a:latin typeface="Lexend Deca" pitchFamily="34" charset="0"/>
+                <a:ea typeface="Lexend Deca" pitchFamily="34" charset="-122"/>
+                <a:cs typeface="Lexend Deca" pitchFamily="34" charset="-120"/>
+              </a:rPr>
+              <a:t>?</a:t>
             </a:r>
             <a:endParaRPr lang="en-US" sz="2200" dirty="0"/>
           </a:p>
@@ -21416,14 +21709,61 @@
       </p:sp>
       <p:sp>
         <p:nvSpPr>
-          <p:cNvPr id="69" name="Rest"/>
-          <p:cNvSpPr/>
-          <p:nvPr/>
-        </p:nvSpPr>
-        <p:spPr>
-          <a:xfrm>
-            <a:off x="5789798" y="4114800"/>
-            <a:ext cx="937260" cy="530352"/>
+          <p:cNvPr id="48" name="Answer bg"/>
+          <p:cNvSpPr/>
+          <p:nvPr/>
+        </p:nvSpPr>
+        <p:spPr>
+          <a:xfrm>
+            <a:off x="6949440" y="4334256"/>
+            <a:ext cx="4526280" cy="786384"/>
+          </a:xfrm>
+          <a:prstGeom prst="roundRect">
+            <a:avLst>
+              <a:gd name="adj" fmla="val 22000"/>
+            </a:avLst>
+          </a:prstGeom>
+          <a:solidFill>
+            <a:srgbClr val="FFFFFF"/>
+          </a:solidFill>
+          <a:ln w="38100">
+            <a:noFill/>
+          </a:ln>
+        </p:spPr>
+        <p:txBody>
+          <a:bodyPr wrap="square" lIns="73152" tIns="36576" rIns="73152" bIns="36576" rtlCol="0" anchor="ctr">
+            <a:noAutofit/>
+          </a:bodyPr>
+          <a:lstStyle/>
+          <a:p>
+            <a:pPr algn="l" indent="0" marL="0">
+              <a:buNone/>
+            </a:pPr>
+            <a:r>
+              <a:rPr lang="en-US" sz="2000" dirty="0">
+                <a:solidFill>
+                  <a:srgbClr val="1B2236"/>
+                </a:solidFill>
+                <a:latin typeface="Lexend Deca" pitchFamily="34" charset="0"/>
+                <a:ea typeface="Lexend Deca" pitchFamily="34" charset="-122"/>
+                <a:cs typeface="Lexend Deca" pitchFamily="34" charset="-120"/>
+              </a:rPr>
+              <a:t/>
+            </a:r>
+            <a:endParaRPr lang="en-US" sz="2000" dirty="0"/>
+          </a:p>
+        </p:txBody>
+      </p:sp>
+      <p:sp>
+        <p:nvSpPr>
+          <p:cNvPr id="47" name="Answer"/>
+          <p:cNvSpPr/>
+          <p:nvPr/>
+        </p:nvSpPr>
+        <p:spPr>
+          <a:xfrm>
+            <a:off x="6949440" y="4315968"/>
+            <a:ext cx="4526280" cy="822960"/>
           </a:xfrm>
           <a:prstGeom prst="rect">
             <a:avLst/>
@@ -21434,7 +21774,7 @@
           </a:ln>
         </p:spPr>
         <p:txBody>
-          <a:bodyPr wrap="square" lIns="0" tIns="36576" rIns="0" bIns="36576" rtlCol="0" anchor="ctr">
+          <a:bodyPr wrap="square" lIns="73152" tIns="36576" rIns="73152" bIns="36576" rtlCol="0" anchor="ctr">
             <a:noAutofit/>
           </a:bodyPr>
           <a:lstStyle/>
@@ -21451,22 +21791,130 @@
                 <a:ea typeface="Lexend Deca" pitchFamily="34" charset="-122"/>
                 <a:cs typeface="Lexend Deca" pitchFamily="34" charset="-120"/>
               </a:rPr>
-              <a:t>I do?</a:t>
+              <a:t>I </a:t>
+            </a:r>
+            <a:r>
+              <a:rPr lang="en-US" sz="2200" dirty="0" b="1">
+                <a:solidFill>
+                  <a:srgbClr val="1B2236"/>
+                </a:solidFill>
+                <a:latin typeface="Lexend Deca" pitchFamily="34" charset="0"/>
+                <a:ea typeface="Lexend Deca" pitchFamily="34" charset="-122"/>
+                <a:cs typeface="Lexend Deca" pitchFamily="34" charset="-120"/>
+              </a:rPr>
+              <a:t>have</a:t>
+            </a:r>
+            <a:r>
+              <a:rPr lang="en-US" sz="2200" dirty="0">
+                <a:solidFill>
+                  <a:srgbClr val="1B2236"/>
+                </a:solidFill>
+                <a:latin typeface="Lexend Deca" pitchFamily="34" charset="0"/>
+                <a:ea typeface="Lexend Deca" pitchFamily="34" charset="-122"/>
+                <a:cs typeface="Lexend Deca" pitchFamily="34" charset="-120"/>
+              </a:rPr>
+              <a:t> a headache.</a:t>
             </a:r>
             <a:endParaRPr lang="en-US" sz="2200" dirty="0"/>
           </a:p>
-        </p:txBody>
-      </p:sp>
-      <p:sp>
-        <p:nvSpPr>
-          <p:cNvPr id="70" name="Wh"/>
-          <p:cNvSpPr/>
-          <p:nvPr/>
-        </p:nvSpPr>
-        <p:spPr>
-          <a:xfrm>
-            <a:off x="3520440" y="4846320"/>
-            <a:ext cx="907999" cy="530352"/>
+          <a:p>
+            <a:pPr algn="l" indent="0" marL="0">
+              <a:buNone/>
+            </a:pPr>
+            <a:r>
+              <a:rPr lang="en-US" sz="2200" dirty="0">
+                <a:solidFill>
+                  <a:srgbClr val="1B2236"/>
+                </a:solidFill>
+                <a:latin typeface="Lexend Deca" pitchFamily="34" charset="0"/>
+                <a:ea typeface="Lexend Deca" pitchFamily="34" charset="-122"/>
+                <a:cs typeface="Lexend Deca" pitchFamily="34" charset="-120"/>
+              </a:rPr>
+              <a:t>My head </a:t>
+            </a:r>
+            <a:r>
+              <a:rPr lang="en-US" sz="2200" dirty="0" b="1">
+                <a:solidFill>
+                  <a:srgbClr val="1B2236"/>
+                </a:solidFill>
+                <a:latin typeface="Lexend Deca" pitchFamily="34" charset="0"/>
+                <a:ea typeface="Lexend Deca" pitchFamily="34" charset="-122"/>
+                <a:cs typeface="Lexend Deca" pitchFamily="34" charset="-120"/>
+              </a:rPr>
+              <a:t>hurts</a:t>
+            </a:r>
+            <a:r>
+              <a:rPr lang="en-US" sz="2200" dirty="0">
+                <a:solidFill>
+                  <a:srgbClr val="1B2236"/>
+                </a:solidFill>
+                <a:latin typeface="Lexend Deca" pitchFamily="34" charset="0"/>
+                <a:ea typeface="Lexend Deca" pitchFamily="34" charset="-122"/>
+                <a:cs typeface="Lexend Deca" pitchFamily="34" charset="-120"/>
+              </a:rPr>
+              <a:t>.</a:t>
+            </a:r>
+            <a:endParaRPr lang="en-US" sz="2200" dirty="0"/>
+          </a:p>
+        </p:txBody>
+      </p:sp>
+      <p:sp>
+        <p:nvSpPr>
+          <p:cNvPr id="49" name="Highlight"/>
+          <p:cNvSpPr/>
+          <p:nvPr/>
+        </p:nvSpPr>
+        <p:spPr>
+          <a:xfrm>
+            <a:off x="1481328" y="5367528"/>
+            <a:ext cx="2281428" cy="548640"/>
+          </a:xfrm>
+          <a:prstGeom prst="roundRect">
+            <a:avLst>
+              <a:gd name="adj" fmla="val 22000"/>
+            </a:avLst>
+          </a:prstGeom>
+          <a:solidFill>
+            <a:srgbClr val="FFE28C"/>
+          </a:solidFill>
+          <a:ln w="38100">
+            <a:noFill/>
+          </a:ln>
+        </p:spPr>
+        <p:txBody>
+          <a:bodyPr wrap="square" lIns="73152" tIns="36576" rIns="73152" bIns="36576" rtlCol="0" anchor="ctr">
+            <a:noAutofit/>
+          </a:bodyPr>
+          <a:lstStyle/>
+          <a:p>
+            <a:pPr algn="l" indent="0" marL="0">
+              <a:buNone/>
+            </a:pPr>
+            <a:r>
+              <a:rPr lang="en-US" sz="2000" dirty="0">
+                <a:solidFill>
+                  <a:srgbClr val="1B2236"/>
+                </a:solidFill>
+                <a:latin typeface="Lexend Deca" pitchFamily="34" charset="0"/>
+                <a:ea typeface="Lexend Deca" pitchFamily="34" charset="-122"/>
+                <a:cs typeface="Lexend Deca" pitchFamily="34" charset="-120"/>
+              </a:rPr>
+              <a:t/>
+            </a:r>
+            <a:endParaRPr lang="en-US" sz="2000" dirty="0"/>
+          </a:p>
+        </p:txBody>
+      </p:sp>
+      <p:sp>
+        <p:nvSpPr>
+          <p:cNvPr id="50" name="Question"/>
+          <p:cNvSpPr/>
+          <p:nvPr/>
+        </p:nvSpPr>
+        <p:spPr>
+          <a:xfrm>
+            <a:off x="1481328" y="5230368"/>
+            <a:ext cx="4526280" cy="822960"/>
           </a:xfrm>
           <a:prstGeom prst="rect">
             <a:avLst/>
@@ -21477,7 +21925,7 @@
           </a:ln>
         </p:spPr>
         <p:txBody>
-          <a:bodyPr wrap="square" lIns="0" tIns="36576" rIns="0" bIns="36576" rtlCol="0" anchor="ctr">
+          <a:bodyPr wrap="square" lIns="73152" tIns="36576" rIns="73152" bIns="36576" rtlCol="0" anchor="ctr">
             <a:noAutofit/>
           </a:bodyPr>
           <a:lstStyle/>
@@ -21494,7 +21942,29 @@
                 <a:ea typeface="Lexend Deca" pitchFamily="34" charset="-122"/>
                 <a:cs typeface="Lexend Deca" pitchFamily="34" charset="-120"/>
               </a:rPr>
-              <a:t>What</a:t>
+              <a:t>What's </a:t>
+            </a:r>
+            <a:r>
+              <a:rPr lang="en-US" sz="2200" dirty="0" b="1">
+                <a:solidFill>
+                  <a:srgbClr val="1B2236"/>
+                </a:solidFill>
+                <a:latin typeface="Lexend Deca" pitchFamily="34" charset="0"/>
+                <a:ea typeface="Lexend Deca" pitchFamily="34" charset="-122"/>
+                <a:cs typeface="Lexend Deca" pitchFamily="34" charset="-120"/>
+              </a:rPr>
+              <a:t>wrong</a:t>
+            </a:r>
+            <a:r>
+              <a:rPr lang="en-US" sz="2200" dirty="0">
+                <a:solidFill>
+                  <a:srgbClr val="1B2236"/>
+                </a:solidFill>
+                <a:latin typeface="Lexend Deca" pitchFamily="34" charset="0"/>
+                <a:ea typeface="Lexend Deca" pitchFamily="34" charset="-122"/>
+                <a:cs typeface="Lexend Deca" pitchFamily="34" charset="-120"/>
+              </a:rPr>
+              <a:t>?</a:t>
             </a:r>
             <a:endParaRPr lang="en-US" sz="2200" dirty="0"/>
           </a:p>
@@ -21502,14 +21972,14 @@
       </p:sp>
       <p:sp>
         <p:nvSpPr>
-          <p:cNvPr id="71" name="Highlight"/>
-          <p:cNvSpPr/>
-          <p:nvPr/>
-        </p:nvSpPr>
-        <p:spPr>
-          <a:xfrm>
-            <a:off x="4428439" y="4846320"/>
-            <a:ext cx="1306495" cy="530352"/>
+          <p:cNvPr id="52" name="Answer bg"/>
+          <p:cNvSpPr/>
+          <p:nvPr/>
+        </p:nvSpPr>
+        <p:spPr>
+          <a:xfrm>
+            <a:off x="6949440" y="5248656"/>
+            <a:ext cx="4526280" cy="786384"/>
           </a:xfrm>
           <a:prstGeom prst="roundRect">
             <a:avLst>
@@ -21517,7 +21987,7 @@
             </a:avLst>
           </a:prstGeom>
           <a:solidFill>
-            <a:srgbClr val="FFE28C"/>
+            <a:srgbClr val="FFFFFF"/>
           </a:solidFill>
           <a:ln w="38100">
             <a:noFill/>
@@ -21549,14 +22019,14 @@
       </p:sp>
       <p:sp>
         <p:nvSpPr>
-          <p:cNvPr id="72" name="Helper"/>
-          <p:cNvSpPr/>
-          <p:nvPr/>
-        </p:nvSpPr>
-        <p:spPr>
-          <a:xfrm>
-            <a:off x="4428439" y="4846320"/>
-            <a:ext cx="1306495" cy="530352"/>
+          <p:cNvPr id="51" name="Answer"/>
+          <p:cNvSpPr/>
+          <p:nvPr/>
+        </p:nvSpPr>
+        <p:spPr>
+          <a:xfrm>
+            <a:off x="6949440" y="5230368"/>
+            <a:ext cx="4526280" cy="822960"/>
           </a:xfrm>
           <a:prstGeom prst="rect">
             <a:avLst/>
@@ -21567,139 +22037,6 @@
           </a:ln>
         </p:spPr>
         <p:txBody>
-          <a:bodyPr wrap="square" lIns="0" tIns="36576" rIns="0" bIns="36576" rtlCol="0" anchor="ctr">
-            <a:noAutofit/>
-          </a:bodyPr>
-          <a:lstStyle/>
-          <a:p>
-            <a:pPr algn="ctr" indent="0" marL="0">
-              <a:buNone/>
-            </a:pPr>
-            <a:r>
-              <a:rPr lang="en-US" sz="2200" dirty="0" b="1">
-                <a:solidFill>
-                  <a:srgbClr val="1B2236"/>
-                </a:solidFill>
-                <a:latin typeface="Lexend Deca" pitchFamily="34" charset="0"/>
-                <a:ea typeface="Lexend Deca" pitchFamily="34" charset="-122"/>
-                <a:cs typeface="Lexend Deca" pitchFamily="34" charset="-120"/>
-              </a:rPr>
-              <a:t>should</a:t>
-            </a:r>
-            <a:endParaRPr lang="en-US" sz="2200" dirty="0"/>
-          </a:p>
-        </p:txBody>
-      </p:sp>
-      <p:sp>
-        <p:nvSpPr>
-          <p:cNvPr id="73" name="Rest"/>
-          <p:cNvSpPr/>
-          <p:nvPr/>
-        </p:nvSpPr>
-        <p:spPr>
-          <a:xfrm>
-            <a:off x="5789798" y="4846320"/>
-            <a:ext cx="1088136" cy="530352"/>
-          </a:xfrm>
-          <a:prstGeom prst="rect">
-            <a:avLst/>
-          </a:prstGeom>
-          <a:noFill/>
-          <a:ln w="38100">
-            <a:noFill/>
-          </a:ln>
-        </p:spPr>
-        <p:txBody>
-          <a:bodyPr wrap="square" lIns="0" tIns="36576" rIns="0" bIns="36576" rtlCol="0" anchor="ctr">
-            <a:noAutofit/>
-          </a:bodyPr>
-          <a:lstStyle/>
-          <a:p>
-            <a:pPr algn="l" indent="0" marL="0">
-              <a:buNone/>
-            </a:pPr>
-            <a:r>
-              <a:rPr lang="en-US" sz="2200" dirty="0">
-                <a:solidFill>
-                  <a:srgbClr val="1B2236"/>
-                </a:solidFill>
-                <a:latin typeface="Lexend Deca" pitchFamily="34" charset="0"/>
-                <a:ea typeface="Lexend Deca" pitchFamily="34" charset="-122"/>
-                <a:cs typeface="Lexend Deca" pitchFamily="34" charset="-120"/>
-              </a:rPr>
-              <a:t>he do?</a:t>
-            </a:r>
-            <a:endParaRPr lang="en-US" sz="2200" dirty="0"/>
-          </a:p>
-        </p:txBody>
-      </p:sp>
-      <p:sp>
-        <p:nvSpPr>
-          <p:cNvPr id="74" name="Wh"/>
-          <p:cNvSpPr/>
-          <p:nvPr/>
-        </p:nvSpPr>
-        <p:spPr>
-          <a:xfrm>
-            <a:off x="3520440" y="5577840"/>
-            <a:ext cx="907999" cy="530352"/>
-          </a:xfrm>
-          <a:prstGeom prst="rect">
-            <a:avLst/>
-          </a:prstGeom>
-          <a:noFill/>
-          <a:ln w="38100">
-            <a:noFill/>
-          </a:ln>
-        </p:spPr>
-        <p:txBody>
-          <a:bodyPr wrap="square" lIns="0" tIns="36576" rIns="0" bIns="36576" rtlCol="0" anchor="ctr">
-            <a:noAutofit/>
-          </a:bodyPr>
-          <a:lstStyle/>
-          <a:p>
-            <a:pPr algn="l" indent="0" marL="0">
-              <a:buNone/>
-            </a:pPr>
-            <a:r>
-              <a:rPr lang="en-US" sz="2200" dirty="0">
-                <a:solidFill>
-                  <a:srgbClr val="1B2236"/>
-                </a:solidFill>
-                <a:latin typeface="Lexend Deca" pitchFamily="34" charset="0"/>
-                <a:ea typeface="Lexend Deca" pitchFamily="34" charset="-122"/>
-                <a:cs typeface="Lexend Deca" pitchFamily="34" charset="-120"/>
-              </a:rPr>
-              <a:t>What</a:t>
-            </a:r>
-            <a:endParaRPr lang="en-US" sz="2200" dirty="0"/>
-          </a:p>
-        </p:txBody>
-      </p:sp>
-      <p:sp>
-        <p:nvSpPr>
-          <p:cNvPr id="75" name="Highlight"/>
-          <p:cNvSpPr/>
-          <p:nvPr/>
-        </p:nvSpPr>
-        <p:spPr>
-          <a:xfrm>
-            <a:off x="4428439" y="5577840"/>
-            <a:ext cx="1306495" cy="530352"/>
-          </a:xfrm>
-          <a:prstGeom prst="roundRect">
-            <a:avLst>
-              <a:gd name="adj" fmla="val 22000"/>
-            </a:avLst>
-          </a:prstGeom>
-          <a:solidFill>
-            <a:srgbClr val="FFE28C"/>
-          </a:solidFill>
-          <a:ln w="38100">
-            <a:noFill/>
-          </a:ln>
-        </p:spPr>
-        <p:txBody>
           <a:bodyPr wrap="square" lIns="73152" tIns="36576" rIns="73152" bIns="36576" rtlCol="0" anchor="ctr">
             <a:noAutofit/>
           </a:bodyPr>
@@ -21709,48 +22046,16 @@
               <a:buNone/>
             </a:pPr>
             <a:r>
-              <a:rPr lang="en-US" sz="2000" dirty="0">
-                <a:solidFill>
-                  <a:srgbClr val="1B2236"/>
-                </a:solidFill>
-                <a:latin typeface="Lexend Deca" pitchFamily="34" charset="0"/>
-                <a:ea typeface="Lexend Deca" pitchFamily="34" charset="-122"/>
-                <a:cs typeface="Lexend Deca" pitchFamily="34" charset="-120"/>
-              </a:rPr>
-              <a:t/>
-            </a:r>
-            <a:endParaRPr lang="en-US" sz="2000" dirty="0"/>
-          </a:p>
-        </p:txBody>
-      </p:sp>
-      <p:sp>
-        <p:nvSpPr>
-          <p:cNvPr id="76" name="Helper"/>
-          <p:cNvSpPr/>
-          <p:nvPr/>
-        </p:nvSpPr>
-        <p:spPr>
-          <a:xfrm>
-            <a:off x="4428439" y="5577840"/>
-            <a:ext cx="1306495" cy="530352"/>
-          </a:xfrm>
-          <a:prstGeom prst="rect">
-            <a:avLst/>
-          </a:prstGeom>
-          <a:noFill/>
-          <a:ln w="38100">
-            <a:noFill/>
-          </a:ln>
-        </p:spPr>
-        <p:txBody>
-          <a:bodyPr wrap="square" lIns="0" tIns="36576" rIns="0" bIns="36576" rtlCol="0" anchor="ctr">
-            <a:noAutofit/>
-          </a:bodyPr>
-          <a:lstStyle/>
-          <a:p>
-            <a:pPr algn="ctr" indent="0" marL="0">
-              <a:buNone/>
-            </a:pPr>
+              <a:rPr lang="en-US" sz="2200" dirty="0">
+                <a:solidFill>
+                  <a:srgbClr val="1B2236"/>
+                </a:solidFill>
+                <a:latin typeface="Lexend Deca" pitchFamily="34" charset="0"/>
+                <a:ea typeface="Lexend Deca" pitchFamily="34" charset="-122"/>
+                <a:cs typeface="Lexend Deca" pitchFamily="34" charset="-120"/>
+              </a:rPr>
+              <a:t>I </a:t>
+            </a:r>
             <a:r>
               <a:rPr lang="en-US" sz="2200" dirty="0" b="1">
                 <a:solidFill>
@@ -21760,36 +22065,21 @@
                 <a:ea typeface="Lexend Deca" pitchFamily="34" charset="-122"/>
                 <a:cs typeface="Lexend Deca" pitchFamily="34" charset="-120"/>
               </a:rPr>
-              <a:t>should</a:t>
+              <a:t>have</a:t>
+            </a:r>
+            <a:r>
+              <a:rPr lang="en-US" sz="2200" dirty="0">
+                <a:solidFill>
+                  <a:srgbClr val="1B2236"/>
+                </a:solidFill>
+                <a:latin typeface="Lexend Deca" pitchFamily="34" charset="0"/>
+                <a:ea typeface="Lexend Deca" pitchFamily="34" charset="-122"/>
+                <a:cs typeface="Lexend Deca" pitchFamily="34" charset="-120"/>
+              </a:rPr>
+              <a:t> a cold.</a:t>
             </a:r>
             <a:endParaRPr lang="en-US" sz="2200" dirty="0"/>
           </a:p>
-        </p:txBody>
-      </p:sp>
-      <p:sp>
-        <p:nvSpPr>
-          <p:cNvPr id="77" name="Rest"/>
-          <p:cNvSpPr/>
-          <p:nvPr/>
-        </p:nvSpPr>
-        <p:spPr>
-          <a:xfrm>
-            <a:off x="5789798" y="5577840"/>
-            <a:ext cx="1239012" cy="530352"/>
-          </a:xfrm>
-          <a:prstGeom prst="rect">
-            <a:avLst/>
-          </a:prstGeom>
-          <a:noFill/>
-          <a:ln w="38100">
-            <a:noFill/>
-          </a:ln>
-        </p:spPr>
-        <p:txBody>
-          <a:bodyPr wrap="square" lIns="0" tIns="36576" rIns="0" bIns="36576" rtlCol="0" anchor="ctr">
-            <a:noAutofit/>
-          </a:bodyPr>
-          <a:lstStyle/>
           <a:p>
             <a:pPr algn="l" indent="0" marL="0">
               <a:buNone/>
@@ -21803,325 +22093,18 @@
                 <a:ea typeface="Lexend Deca" pitchFamily="34" charset="-122"/>
                 <a:cs typeface="Lexend Deca" pitchFamily="34" charset="-120"/>
               </a:rPr>
-              <a:t>she do?</a:t>
-            </a:r>
-            <a:endParaRPr lang="en-US" sz="2200" dirty="0"/>
-          </a:p>
-        </p:txBody>
-      </p:sp>
-      <p:sp>
-        <p:nvSpPr>
-          <p:cNvPr id="78" name="Card head"/>
-          <p:cNvSpPr/>
-          <p:nvPr/>
-        </p:nvSpPr>
-        <p:spPr>
-          <a:xfrm>
-            <a:off x="8549640" y="1280160"/>
-            <a:ext cx="3017520" cy="548640"/>
-          </a:xfrm>
-          <a:prstGeom prst="rect">
-            <a:avLst/>
-          </a:prstGeom>
-          <a:noFill/>
-          <a:ln w="38100">
-            <a:noFill/>
-          </a:ln>
-        </p:spPr>
-        <p:txBody>
-          <a:bodyPr wrap="square" lIns="73152" tIns="36576" rIns="73152" bIns="36576" rtlCol="0" anchor="ctr">
-            <a:noAutofit/>
-          </a:bodyPr>
-          <a:lstStyle/>
-          <a:p>
-            <a:pPr algn="l" indent="0" marL="0">
-              <a:buNone/>
-            </a:pPr>
-            <a:r>
-              <a:rPr lang="en-US" sz="2400" dirty="0" b="1">
-                <a:solidFill>
-                  <a:srgbClr val="1B2236"/>
-                </a:solidFill>
-                <a:latin typeface="Lexend Deca" pitchFamily="34" charset="0"/>
-                <a:ea typeface="Lexend Deca" pitchFamily="34" charset="-122"/>
-                <a:cs typeface="Lexend Deca" pitchFamily="34" charset="-120"/>
-              </a:rPr>
-              <a:t>Advice</a:t>
-            </a:r>
-            <a:endParaRPr lang="en-US" sz="2400" dirty="0"/>
-          </a:p>
-        </p:txBody>
-      </p:sp>
-      <p:sp>
-        <p:nvSpPr>
-          <p:cNvPr id="79" name="Card item"/>
-          <p:cNvSpPr/>
-          <p:nvPr/>
-        </p:nvSpPr>
-        <p:spPr>
-          <a:xfrm>
-            <a:off x="8549640" y="1920240"/>
-            <a:ext cx="3017520" cy="457200"/>
-          </a:xfrm>
-          <a:prstGeom prst="rect">
-            <a:avLst/>
-          </a:prstGeom>
-          <a:noFill/>
-          <a:ln w="38100">
-            <a:noFill/>
-          </a:ln>
-        </p:spPr>
-        <p:txBody>
-          <a:bodyPr wrap="square" lIns="73152" tIns="36576" rIns="73152" bIns="36576" rtlCol="0" anchor="ctr">
-            <a:noAutofit/>
-          </a:bodyPr>
-          <a:lstStyle/>
-          <a:p>
-            <a:pPr algn="l" indent="0" marL="0">
-              <a:buNone/>
-            </a:pPr>
-            <a:r>
-              <a:rPr lang="en-US" sz="2000" dirty="0">
-                <a:solidFill>
-                  <a:srgbClr val="1B2236"/>
-                </a:solidFill>
-                <a:latin typeface="Lexend Deca" pitchFamily="34" charset="0"/>
-                <a:ea typeface="Lexend Deca" pitchFamily="34" charset="-122"/>
-                <a:cs typeface="Lexend Deca" pitchFamily="34" charset="-120"/>
-              </a:rPr>
-              <a:t>You </a:t>
-            </a:r>
-            <a:r>
-              <a:rPr lang="en-US" sz="2000" dirty="0" b="1">
-                <a:solidFill>
-                  <a:srgbClr val="5B3FC4"/>
-                </a:solidFill>
-                <a:latin typeface="Lexend Deca" pitchFamily="34" charset="0"/>
-                <a:ea typeface="Lexend Deca" pitchFamily="34" charset="-122"/>
-                <a:cs typeface="Lexend Deca" pitchFamily="34" charset="-120"/>
-              </a:rPr>
-              <a:t>should</a:t>
-            </a:r>
-            <a:r>
-              <a:rPr lang="en-US" sz="2000" dirty="0">
-                <a:solidFill>
-                  <a:srgbClr val="1B2236"/>
-                </a:solidFill>
-                <a:latin typeface="Lexend Deca" pitchFamily="34" charset="0"/>
-                <a:ea typeface="Lexend Deca" pitchFamily="34" charset="-122"/>
-                <a:cs typeface="Lexend Deca" pitchFamily="34" charset="-120"/>
-              </a:rPr>
-              <a:t> rest.</a:t>
-            </a:r>
-            <a:endParaRPr lang="en-US" sz="2000" dirty="0"/>
-          </a:p>
-        </p:txBody>
-      </p:sp>
-      <p:sp>
-        <p:nvSpPr>
-          <p:cNvPr id="80" name="Card item"/>
-          <p:cNvSpPr/>
-          <p:nvPr/>
-        </p:nvSpPr>
-        <p:spPr>
-          <a:xfrm>
-            <a:off x="8549640" y="2404872"/>
-            <a:ext cx="3017520" cy="777240"/>
-          </a:xfrm>
-          <a:prstGeom prst="rect">
-            <a:avLst/>
-          </a:prstGeom>
-          <a:noFill/>
-          <a:ln w="38100">
-            <a:noFill/>
-          </a:ln>
-        </p:spPr>
-        <p:txBody>
-          <a:bodyPr wrap="square" lIns="73152" tIns="36576" rIns="73152" bIns="36576" rtlCol="0" anchor="ctr">
-            <a:noAutofit/>
-          </a:bodyPr>
-          <a:lstStyle/>
-          <a:p>
-            <a:pPr algn="l" indent="0" marL="0">
-              <a:buNone/>
-            </a:pPr>
-            <a:r>
-              <a:rPr lang="en-US" sz="2000" dirty="0">
-                <a:solidFill>
-                  <a:srgbClr val="1B2236"/>
-                </a:solidFill>
-                <a:latin typeface="Lexend Deca" pitchFamily="34" charset="0"/>
-                <a:ea typeface="Lexend Deca" pitchFamily="34" charset="-122"/>
-                <a:cs typeface="Lexend Deca" pitchFamily="34" charset="-120"/>
-              </a:rPr>
-              <a:t>He </a:t>
-            </a:r>
-            <a:r>
-              <a:rPr lang="en-US" sz="2000" dirty="0" b="1">
-                <a:solidFill>
-                  <a:srgbClr val="5B3FC4"/>
-                </a:solidFill>
-                <a:latin typeface="Lexend Deca" pitchFamily="34" charset="0"/>
-                <a:ea typeface="Lexend Deca" pitchFamily="34" charset="-122"/>
-                <a:cs typeface="Lexend Deca" pitchFamily="34" charset="-120"/>
-              </a:rPr>
-              <a:t>should</a:t>
-            </a:r>
-            <a:r>
-              <a:rPr lang="en-US" sz="2000" dirty="0">
-                <a:solidFill>
-                  <a:srgbClr val="1B2236"/>
-                </a:solidFill>
-                <a:latin typeface="Lexend Deca" pitchFamily="34" charset="0"/>
-                <a:ea typeface="Lexend Deca" pitchFamily="34" charset="-122"/>
-                <a:cs typeface="Lexend Deca" pitchFamily="34" charset="-120"/>
-              </a:rPr>
-              <a:t> see a doctor.</a:t>
-            </a:r>
-            <a:endParaRPr lang="en-US" sz="2000" dirty="0"/>
-          </a:p>
-        </p:txBody>
-      </p:sp>
-      <p:sp>
-        <p:nvSpPr>
-          <p:cNvPr id="81" name="Card item"/>
-          <p:cNvSpPr/>
-          <p:nvPr/>
-        </p:nvSpPr>
-        <p:spPr>
-          <a:xfrm>
-            <a:off x="8549640" y="3209544"/>
-            <a:ext cx="3017520" cy="777240"/>
-          </a:xfrm>
-          <a:prstGeom prst="rect">
-            <a:avLst/>
-          </a:prstGeom>
-          <a:noFill/>
-          <a:ln w="38100">
-            <a:noFill/>
-          </a:ln>
-        </p:spPr>
-        <p:txBody>
-          <a:bodyPr wrap="square" lIns="73152" tIns="36576" rIns="73152" bIns="36576" rtlCol="0" anchor="ctr">
-            <a:noAutofit/>
-          </a:bodyPr>
-          <a:lstStyle/>
-          <a:p>
-            <a:pPr algn="l" indent="0" marL="0">
-              <a:buNone/>
-            </a:pPr>
-            <a:r>
-              <a:rPr lang="en-US" sz="2000" dirty="0">
-                <a:solidFill>
-                  <a:srgbClr val="1B2236"/>
-                </a:solidFill>
-                <a:latin typeface="Lexend Deca" pitchFamily="34" charset="0"/>
-                <a:ea typeface="Lexend Deca" pitchFamily="34" charset="-122"/>
-                <a:cs typeface="Lexend Deca" pitchFamily="34" charset="-120"/>
-              </a:rPr>
-              <a:t>She </a:t>
-            </a:r>
-            <a:r>
-              <a:rPr lang="en-US" sz="2000" dirty="0" b="1">
-                <a:solidFill>
-                  <a:srgbClr val="5B3FC4"/>
-                </a:solidFill>
-                <a:latin typeface="Lexend Deca" pitchFamily="34" charset="0"/>
-                <a:ea typeface="Lexend Deca" pitchFamily="34" charset="-122"/>
-                <a:cs typeface="Lexend Deca" pitchFamily="34" charset="-120"/>
-              </a:rPr>
-              <a:t>shouldn't</a:t>
-            </a:r>
-            <a:r>
-              <a:rPr lang="en-US" sz="2000" dirty="0">
-                <a:solidFill>
-                  <a:srgbClr val="1B2236"/>
-                </a:solidFill>
-                <a:latin typeface="Lexend Deca" pitchFamily="34" charset="0"/>
-                <a:ea typeface="Lexend Deca" pitchFamily="34" charset="-122"/>
-                <a:cs typeface="Lexend Deca" pitchFamily="34" charset="-120"/>
-              </a:rPr>
-              <a:t> go to work.</a:t>
-            </a:r>
-            <a:endParaRPr lang="en-US" sz="2000" dirty="0"/>
-          </a:p>
-        </p:txBody>
-      </p:sp>
-      <p:sp>
-        <p:nvSpPr>
-          <p:cNvPr id="82" name="Example"/>
-          <p:cNvSpPr/>
-          <p:nvPr/>
-        </p:nvSpPr>
-        <p:spPr>
-          <a:xfrm>
-            <a:off x="8549640" y="5394960"/>
-            <a:ext cx="3017520" cy="502920"/>
-          </a:xfrm>
-          <a:prstGeom prst="roundRect">
-            <a:avLst>
-              <a:gd name="adj" fmla="val 22000"/>
-            </a:avLst>
-          </a:prstGeom>
-          <a:solidFill>
-            <a:srgbClr val="FFFFFF"/>
-          </a:solidFill>
-          <a:ln w="38100">
-            <a:noFill/>
-          </a:ln>
-        </p:spPr>
-        <p:txBody>
-          <a:bodyPr wrap="square" lIns="73152" tIns="36576" rIns="73152" bIns="36576" rtlCol="0" anchor="ctr">
-            <a:noAutofit/>
-          </a:bodyPr>
-          <a:lstStyle/>
-          <a:p>
-            <a:pPr algn="ctr" indent="0" marL="0">
-              <a:buNone/>
-            </a:pPr>
-            <a:r>
-              <a:rPr lang="en-US" sz="2200" dirty="0">
-                <a:solidFill>
-                  <a:srgbClr val="1B2236"/>
-                </a:solidFill>
-                <a:latin typeface="Lexend Deca" pitchFamily="34" charset="0"/>
-                <a:ea typeface="Lexend Deca" pitchFamily="34" charset="-122"/>
-                <a:cs typeface="Lexend Deca" pitchFamily="34" charset="-120"/>
-              </a:rPr>
-              <a:t>No </a:t>
+              <a:t>My feet </a:t>
             </a:r>
             <a:r>
               <a:rPr lang="en-US" sz="2200" dirty="0" b="1">
                 <a:solidFill>
-                  <a:srgbClr val="5B3FC4"/>
-                </a:solidFill>
-                <a:latin typeface="Lexend Deca" pitchFamily="34" charset="0"/>
-                <a:ea typeface="Lexend Deca" pitchFamily="34" charset="-122"/>
-                <a:cs typeface="Lexend Deca" pitchFamily="34" charset="-120"/>
-              </a:rPr>
-              <a:t>to</a:t>
-            </a:r>
-            <a:r>
-              <a:rPr lang="en-US" sz="2200" dirty="0">
-                <a:solidFill>
-                  <a:srgbClr val="1B2236"/>
-                </a:solidFill>
-                <a:latin typeface="Lexend Deca" pitchFamily="34" charset="0"/>
-                <a:ea typeface="Lexend Deca" pitchFamily="34" charset="-122"/>
-                <a:cs typeface="Lexend Deca" pitchFamily="34" charset="-120"/>
-              </a:rPr>
-              <a:t>. No </a:t>
-            </a:r>
-            <a:r>
-              <a:rPr lang="en-US" sz="2200" dirty="0" b="1">
-                <a:solidFill>
-                  <a:srgbClr val="5B3FC4"/>
-                </a:solidFill>
-                <a:latin typeface="Lexend Deca" pitchFamily="34" charset="0"/>
-                <a:ea typeface="Lexend Deca" pitchFamily="34" charset="-122"/>
-                <a:cs typeface="Lexend Deca" pitchFamily="34" charset="-120"/>
-              </a:rPr>
-              <a:t>-s</a:t>
+                  <a:srgbClr val="1B2236"/>
+                </a:solidFill>
+                <a:latin typeface="Lexend Deca" pitchFamily="34" charset="0"/>
+                <a:ea typeface="Lexend Deca" pitchFamily="34" charset="-122"/>
+                <a:cs typeface="Lexend Deca" pitchFamily="34" charset="-120"/>
+              </a:rPr>
+              <a:t>hurt</a:t>
             </a:r>
             <a:r>
               <a:rPr lang="en-US" sz="2200" dirty="0">
@@ -22177,7 +22160,7 @@
                                           </p:stCondLst>
                                         </p:cTn>
                                         <p:tgtEl>
-                                          <p:spTgt spid="67"/>
+                                          <p:spTgt spid="45"/>
                                         </p:tgtEl>
                                         <p:attrNameLst>
                                           <p:attrName>style.visibility</p:attrName>
@@ -22191,7 +22174,42 @@
                                       <p:cBhvr>
                                         <p:cTn id="7" dur="400"/>
                                         <p:tgtEl>
-                                          <p:spTgt spid="67"/>
+                                          <p:spTgt spid="45"/>
+                                        </p:tgtEl>
+                                      </p:cBhvr>
+                                    </p:animEffect>
+                                  </p:childTnLst>
+                                </p:cTn>
+                              </p:par>
+                              <p:par>
+                                <p:cTn id="8" presetID="10" presetClass="entr" presetSubtype="0" fill="hold" nodeType="withEffect">
+                                  <p:stCondLst>
+                                    <p:cond delay="0"/>
+                                  </p:stCondLst>
+                                  <p:childTnLst>
+                                    <p:set>
+                                      <p:cBhvr>
+                                        <p:cTn id="9" dur="1" fill="hold">
+                                          <p:stCondLst>
+                                            <p:cond delay="0"/>
+                                          </p:stCondLst>
+                                        </p:cTn>
+                                        <p:tgtEl>
+                                          <p:spTgt spid="48"/>
+                                        </p:tgtEl>
+                                        <p:attrNameLst>
+                                          <p:attrName>style.visibility</p:attrName>
+                                        </p:attrNameLst>
+                                      </p:cBhvr>
+                                      <p:to>
+                                        <p:strVal val="visible"/>
+                                      </p:to>
+                                    </p:set>
+                                    <p:animEffect transition="in" filter="fade">
+                                      <p:cBhvr>
+                                        <p:cTn id="10" dur="400"/>
+                                        <p:tgtEl>
+                                          <p:spTgt spid="48"/>
                                         </p:tgtEl>
                                       </p:cBhvr>
                                     </p:animEffect>
@@ -22205,32 +22223,32 @@
                     </p:cTn>
                   </p:par>
                   <p:par>
-                    <p:cTn id="8" fill="hold">
+                    <p:cTn id="11" fill="hold">
                       <p:stCondLst>
                         <p:cond delay="indefinite"/>
                       </p:stCondLst>
                       <p:childTnLst>
                         <p:par>
-                          <p:cTn id="9" fill="hold">
+                          <p:cTn id="12" fill="hold">
                             <p:stCondLst>
                               <p:cond delay="0"/>
                             </p:stCondLst>
                             <p:childTnLst>
                               <p:par>
-                                <p:cTn id="10" presetID="10" presetClass="entr" presetSubtype="0" fill="hold" nodeType="clickEffect">
+                                <p:cTn id="13" presetID="10" presetClass="entr" presetSubtype="0" fill="hold" nodeType="clickEffect">
                                   <p:stCondLst>
                                     <p:cond delay="0"/>
                                   </p:stCondLst>
                                   <p:childTnLst>
                                     <p:set>
                                       <p:cBhvr>
-                                        <p:cTn id="11" dur="1" fill="hold">
+                                        <p:cTn id="14" dur="1" fill="hold">
                                           <p:stCondLst>
                                             <p:cond delay="0"/>
                                           </p:stCondLst>
                                         </p:cTn>
                                         <p:tgtEl>
-                                          <p:spTgt spid="71"/>
+                                          <p:spTgt spid="49"/>
                                         </p:tgtEl>
                                         <p:attrNameLst>
                                           <p:attrName>style.visibility</p:attrName>
@@ -22242,48 +22260,30 @@
                                     </p:set>
                                     <p:animEffect transition="in" filter="fade">
                                       <p:cBhvr>
-                                        <p:cTn id="12" dur="400"/>
+                                        <p:cTn id="15" dur="400"/>
                                         <p:tgtEl>
-                                          <p:spTgt spid="71"/>
+                                          <p:spTgt spid="49"/>
                                         </p:tgtEl>
                                       </p:cBhvr>
                                     </p:animEffect>
                                   </p:childTnLst>
                                 </p:cTn>
                               </p:par>
-                            </p:childTnLst>
-                          </p:cTn>
-                        </p:par>
-                      </p:childTnLst>
-                    </p:cTn>
-                  </p:par>
-                  <p:par>
-                    <p:cTn id="13" fill="hold">
-                      <p:stCondLst>
-                        <p:cond delay="indefinite"/>
-                      </p:stCondLst>
-                      <p:childTnLst>
-                        <p:par>
-                          <p:cTn id="14" fill="hold">
-                            <p:stCondLst>
-                              <p:cond delay="0"/>
-                            </p:stCondLst>
-                            <p:childTnLst>
                               <p:par>
-                                <p:cTn id="15" presetID="10" presetClass="entr" presetSubtype="0" fill="hold" nodeType="clickEffect">
+                                <p:cTn id="16" presetID="10" presetClass="entr" presetSubtype="0" fill="hold" nodeType="withEffect">
                                   <p:stCondLst>
                                     <p:cond delay="0"/>
                                   </p:stCondLst>
                                   <p:childTnLst>
                                     <p:set>
                                       <p:cBhvr>
-                                        <p:cTn id="16" dur="1" fill="hold">
+                                        <p:cTn id="17" dur="1" fill="hold">
                                           <p:stCondLst>
                                             <p:cond delay="0"/>
                                           </p:stCondLst>
                                         </p:cTn>
                                         <p:tgtEl>
-                                          <p:spTgt spid="75"/>
+                                          <p:spTgt spid="52"/>
                                         </p:tgtEl>
                                         <p:attrNameLst>
                                           <p:attrName>style.visibility</p:attrName>
@@ -22295,9 +22295,9 @@
                                     </p:set>
                                     <p:animEffect transition="in" filter="fade">
                                       <p:cBhvr>
-                                        <p:cTn id="17" dur="400"/>
+                                        <p:cTn id="18" dur="400"/>
                                         <p:tgtEl>
-                                          <p:spTgt spid="75"/>
+                                          <p:spTgt spid="52"/>
                                         </p:tgtEl>
                                       </p:cBhvr>
                                     </p:animEffect>

</xml_diff>